<commit_message>
feat: modelo estrela de 20 tabelas e PPTX atualizado
- 02_modelo_estrela.sql: 8 dimensoes + 4 fatos (modelo de 20 tabelas)
- 03_carga_estrela.sql: ETL raw_* -> dimensoes/fatos (transacional)
- PPTX: slide de modelagem agora mostra as 20 tabelas (staging/dim/fato)
  + nova slide mapeando as 20 tabelas as 10 perguntas de negocio

Co-Authored-By: Claude Opus 4.8 <noreply@anthropic.com>
</commit_message>
<xml_diff>
--- a/analise_olist/Apresentacao_Olist.pptx
+++ b/analise_olist/Apresentacao_Olist.pptx
@@ -19,6 +19,7 @@
     <p:sldId id="267" r:id="rId18"/>
     <p:sldId id="268" r:id="rId19"/>
     <p:sldId id="269" r:id="rId20"/>
+    <p:sldId id="270" r:id="rId21"/>
   </p:sldIdLst>
   <p:sldSz cx="12191695" cy="6858000" type="screen4x3"/>
   <p:notesSz cx="6858000" cy="9144000"/>
@@ -4170,7 +4171,7 @@
                 </a:solidFill>
                 <a:latin typeface="Calibri"/>
               </a:rPr>
-              <a:t>•  **Volume analisado:** ~100 mil pedidos · 8 tabelas · 550.759 registros</a:t>
+              <a:t>•  **Volume analisado:** ~100 mil pedidos · modelo estrela de 20 tabelas (8 staging + 8 dim + 4 fato)</a:t>
             </a:r>
           </a:p>
           <a:p>
@@ -4362,7 +4363,7 @@
                 </a:solidFill>
                 <a:latin typeface="Calibri"/>
               </a:rPr>
-              <a:t>Logística e Cancelamentos (P7 e P8)</a:t>
+              <a:t>Categorias e Crescimento (P5 e P6)</a:t>
             </a:r>
           </a:p>
         </p:txBody>
@@ -4481,13 +4482,13 @@
           <a:p>
             <a:pPr algn="ctr"/>
             <a:r>
-              <a:rPr sz="2200" b="1">
+              <a:rPr sz="1600" b="1">
                 <a:solidFill>
                   <a:srgbClr val="1F3864"/>
                 </a:solidFill>
                 <a:latin typeface="Calibri"/>
               </a:rPr>
-              <a:t>12,5 dias</a:t>
+              <a:t>cama/mesa/banho</a:t>
             </a:r>
           </a:p>
         </p:txBody>
@@ -4522,7 +4523,7 @@
                 </a:solidFill>
                 <a:latin typeface="Calibri"/>
               </a:rPr>
-              <a:t>entrega média</a:t>
+              <a:t>+ vendida</a:t>
             </a:r>
           </a:p>
         </p:txBody>
@@ -4597,13 +4598,13 @@
           <a:p>
             <a:pPr algn="ctr"/>
             <a:r>
-              <a:rPr sz="3000" b="1">
+              <a:rPr sz="1600" b="1">
                 <a:solidFill>
                   <a:srgbClr val="1F3864"/>
                 </a:solidFill>
                 <a:latin typeface="Calibri"/>
               </a:rPr>
-              <a:t>93,2%</a:t>
+              <a:t>health_beauty</a:t>
             </a:r>
           </a:p>
         </p:txBody>
@@ -4638,7 +4639,7 @@
                 </a:solidFill>
                 <a:latin typeface="Calibri"/>
               </a:rPr>
-              <a:t>no prazo</a:t>
+              <a:t>+ receita</a:t>
             </a:r>
           </a:p>
         </p:txBody>
@@ -4719,7 +4720,7 @@
                 </a:solidFill>
                 <a:latin typeface="Calibri"/>
               </a:rPr>
-              <a:t>0,6%</a:t>
+              <a:t>+52%</a:t>
             </a:r>
           </a:p>
         </p:txBody>
@@ -4754,7 +4755,7 @@
                 </a:solidFill>
                 <a:latin typeface="Calibri"/>
               </a:rPr>
-              <a:t>cancelados</a:t>
+              <a:t>MoM em nov/2017</a:t>
             </a:r>
           </a:p>
         </p:txBody>
@@ -4811,7 +4812,23 @@
                 </a:solidFill>
                 <a:latin typeface="Calibri"/>
               </a:rPr>
-              <a:t>•  **Insight:** logística saudável — 93% no prazo, ~12 dias.</a:t>
+              <a:t>•  **Insight:** volume vem de cama/mesa/banho; receita de</a:t>
+            </a:r>
+          </a:p>
+          <a:p>
+            <a:pPr lvl="1">
+              <a:spcAft>
+                <a:spcPts val="1000"/>
+              </a:spcAft>
+            </a:pPr>
+            <a:r>
+              <a:rPr sz="1300" b="0">
+                <a:solidFill>
+                  <a:srgbClr val="595959"/>
+                </a:solidFill>
+                <a:latin typeface="Calibri"/>
+              </a:rPr>
+              <a:t>–  saúde &amp; beleza e relógios/presentes (ticket maior).</a:t>
             </a:r>
           </a:p>
           <a:p>
@@ -4827,23 +4844,7 @@
                 </a:solidFill>
                 <a:latin typeface="Calibri"/>
               </a:rPr>
-              <a:t>•  **Cancelamento:** o Olist não traz 'motivo' textual;</a:t>
-            </a:r>
-          </a:p>
-          <a:p>
-            <a:pPr lvl="1">
-              <a:spcAft>
-                <a:spcPts val="1000"/>
-              </a:spcAft>
-            </a:pPr>
-            <a:r>
-              <a:rPr sz="1300" b="0">
-                <a:solidFill>
-                  <a:srgbClr val="595959"/>
-                </a:solidFill>
-                <a:latin typeface="Calibri"/>
-              </a:rPr>
-              <a:t>–  'unavailable' (0,6%) sugere ruptura de estoque.</a:t>
+              <a:t>•  **Tendência:** crescimento forte em 2017, estabiliza em 2018.</a:t>
             </a:r>
           </a:p>
           <a:p>
@@ -4859,7 +4860,7 @@
                 </a:solidFill>
                 <a:latin typeface="Calibri"/>
               </a:rPr>
-              <a:t>•  **Ação:** monitorar estoque e prazos das categorias críticas.</a:t>
+              <a:t>•  **Ação:** mix de produtos por margem e curva de demanda.</a:t>
             </a:r>
           </a:p>
         </p:txBody>
@@ -5035,7 +5036,7 @@
                 </a:solidFill>
                 <a:latin typeface="Calibri"/>
               </a:rPr>
-              <a:t>Vendedores e Satisfação (P9 e P10)</a:t>
+              <a:t>Logística e Cancelamentos (P7 e P8)</a:t>
             </a:r>
           </a:p>
         </p:txBody>
@@ -5160,7 +5161,7 @@
                 </a:solidFill>
                 <a:latin typeface="Calibri"/>
               </a:rPr>
-              <a:t>R$ 229 mil</a:t>
+              <a:t>12,5 dias</a:t>
             </a:r>
           </a:p>
         </p:txBody>
@@ -5195,7 +5196,7 @@
                 </a:solidFill>
                 <a:latin typeface="Calibri"/>
               </a:rPr>
-              <a:t>top seller</a:t>
+              <a:t>entrega média</a:t>
             </a:r>
           </a:p>
         </p:txBody>
@@ -5276,7 +5277,7 @@
                 </a:solidFill>
                 <a:latin typeface="Calibri"/>
               </a:rPr>
-              <a:t>4,09/5</a:t>
+              <a:t>93,2%</a:t>
             </a:r>
           </a:p>
         </p:txBody>
@@ -5311,7 +5312,7 @@
                 </a:solidFill>
                 <a:latin typeface="Calibri"/>
               </a:rPr>
-              <a:t>nota média</a:t>
+              <a:t>no prazo</a:t>
             </a:r>
           </a:p>
         </p:txBody>
@@ -5392,7 +5393,7 @@
                 </a:solidFill>
                 <a:latin typeface="Calibri"/>
               </a:rPr>
-              <a:t>14,7%</a:t>
+              <a:t>0,6%</a:t>
             </a:r>
           </a:p>
         </p:txBody>
@@ -5427,7 +5428,7 @@
                 </a:solidFill>
                 <a:latin typeface="Calibri"/>
               </a:rPr>
-              <a:t>insatisfeitos</a:t>
+              <a:t>cancelados</a:t>
             </a:r>
           </a:p>
         </p:txBody>
@@ -5484,7 +5485,7 @@
                 </a:solidFill>
                 <a:latin typeface="Calibri"/>
               </a:rPr>
-              <a:t>•  **Insight:** receita concentrada em poucos sellers de SP.</a:t>
+              <a:t>•  **Insight:** logística saudável — 93% no prazo, ~12 dias.</a:t>
             </a:r>
           </a:p>
           <a:p>
@@ -5500,7 +5501,7 @@
                 </a:solidFill>
                 <a:latin typeface="Calibri"/>
               </a:rPr>
-              <a:t>•  **Satisfação:** boa média (4,09), mas 14,7% dão nota 1-2.</a:t>
+              <a:t>•  **Cancelamento:** o Olist não traz 'motivo' textual;</a:t>
             </a:r>
           </a:p>
           <a:p>
@@ -5516,7 +5517,7 @@
                 </a:solidFill>
                 <a:latin typeface="Calibri"/>
               </a:rPr>
-              <a:t>–  11,5% dão nota 1 — cauda de insatisfação relevante.</a:t>
+              <a:t>–  'unavailable' (0,6%) sugere ruptura de estoque.</a:t>
             </a:r>
           </a:p>
           <a:p>
@@ -5532,7 +5533,7 @@
                 </a:solidFill>
                 <a:latin typeface="Calibri"/>
               </a:rPr>
-              <a:t>•  **Ação:** plano de qualidade para sellers e SAC proativo.</a:t>
+              <a:t>•  **Ação:** monitorar estoque e prazos das categorias críticas.</a:t>
             </a:r>
           </a:p>
         </p:txBody>
@@ -5673,7 +5674,7 @@
                 </a:solidFill>
                 <a:latin typeface="Calibri"/>
               </a:rPr>
-              <a:t>Etapa 5 — Gestão e Governança</a:t>
+              <a:t>Etapa 4 — Análise de Dados e Insights</a:t>
             </a:r>
           </a:p>
         </p:txBody>
@@ -5708,7 +5709,7 @@
                 </a:solidFill>
                 <a:latin typeface="Calibri"/>
               </a:rPr>
-              <a:t>Organização, Governança e Git</a:t>
+              <a:t>Vendedores e Satisfação (P9 e P10)</a:t>
             </a:r>
           </a:p>
         </p:txBody>
@@ -5759,14 +5760,380 @@
       </p:sp>
       <p:sp>
         <p:nvSpPr>
-          <p:cNvPr id="7" name="TextBox 6"/>
+          <p:cNvPr id="7" name="Rectangle 6"/>
+          <p:cNvSpPr/>
+          <p:nvPr/>
+        </p:nvSpPr>
+        <p:spPr>
+          <a:xfrm>
+            <a:off x="640080" y="1691640"/>
+            <a:ext cx="2651760" cy="1371600"/>
+          </a:xfrm>
+          <a:prstGeom prst="rect">
+            <a:avLst/>
+          </a:prstGeom>
+          <a:solidFill>
+            <a:srgbClr val="FFFFFF"/>
+          </a:solidFill>
+          <a:ln w="12700">
+            <a:solidFill>
+              <a:srgbClr val="2E5496"/>
+            </a:solidFill>
+          </a:ln>
+          <a:effectLst/>
+        </p:spPr>
+        <p:style>
+          <a:lnRef idx="1">
+            <a:schemeClr val="accent1"/>
+          </a:lnRef>
+          <a:fillRef idx="3">
+            <a:schemeClr val="accent1"/>
+          </a:fillRef>
+          <a:effectRef idx="2">
+            <a:schemeClr val="accent1"/>
+          </a:effectRef>
+          <a:fontRef idx="minor">
+            <a:schemeClr val="lt1"/>
+          </a:fontRef>
+        </p:style>
+        <p:txBody>
+          <a:bodyPr rtlCol="0" anchor="ctr"/>
+          <a:lstStyle/>
+          <a:p>
+            <a:pPr algn="ctr"/>
+          </a:p>
+        </p:txBody>
+      </p:sp>
+      <p:sp>
+        <p:nvSpPr>
+          <p:cNvPr id="8" name="TextBox 7"/>
           <p:cNvSpPr txBox="1"/>
           <p:nvPr/>
         </p:nvSpPr>
         <p:spPr>
           <a:xfrm>
-            <a:off x="640080" y="1737360"/>
-            <a:ext cx="10972800" cy="4572000"/>
+            <a:off x="640080" y="1856232"/>
+            <a:ext cx="2651760" cy="640080"/>
+          </a:xfrm>
+          <a:prstGeom prst="rect">
+            <a:avLst/>
+          </a:prstGeom>
+          <a:noFill/>
+        </p:spPr>
+        <p:txBody>
+          <a:bodyPr wrap="square" anchor="ctr">
+            <a:spAutoFit/>
+          </a:bodyPr>
+          <a:lstStyle/>
+          <a:p>
+            <a:pPr algn="ctr"/>
+            <a:r>
+              <a:rPr sz="2200" b="1">
+                <a:solidFill>
+                  <a:srgbClr val="1F3864"/>
+                </a:solidFill>
+                <a:latin typeface="Calibri"/>
+              </a:rPr>
+              <a:t>R$ 229 mil</a:t>
+            </a:r>
+          </a:p>
+        </p:txBody>
+      </p:sp>
+      <p:sp>
+        <p:nvSpPr>
+          <p:cNvPr id="9" name="TextBox 8"/>
+          <p:cNvSpPr txBox="1"/>
+          <p:nvPr/>
+        </p:nvSpPr>
+        <p:spPr>
+          <a:xfrm>
+            <a:off x="640080" y="2560320"/>
+            <a:ext cx="2651760" cy="411480"/>
+          </a:xfrm>
+          <a:prstGeom prst="rect">
+            <a:avLst/>
+          </a:prstGeom>
+          <a:noFill/>
+        </p:spPr>
+        <p:txBody>
+          <a:bodyPr wrap="square" anchor="t">
+            <a:spAutoFit/>
+          </a:bodyPr>
+          <a:lstStyle/>
+          <a:p>
+            <a:pPr algn="ctr"/>
+            <a:r>
+              <a:rPr sz="1200" b="0">
+                <a:solidFill>
+                  <a:srgbClr val="595959"/>
+                </a:solidFill>
+                <a:latin typeface="Calibri"/>
+              </a:rPr>
+              <a:t>top seller</a:t>
+            </a:r>
+          </a:p>
+        </p:txBody>
+      </p:sp>
+      <p:sp>
+        <p:nvSpPr>
+          <p:cNvPr id="10" name="Rectangle 9"/>
+          <p:cNvSpPr/>
+          <p:nvPr/>
+        </p:nvSpPr>
+        <p:spPr>
+          <a:xfrm>
+            <a:off x="3429000" y="1691640"/>
+            <a:ext cx="2651760" cy="1371600"/>
+          </a:xfrm>
+          <a:prstGeom prst="rect">
+            <a:avLst/>
+          </a:prstGeom>
+          <a:solidFill>
+            <a:srgbClr val="FFFFFF"/>
+          </a:solidFill>
+          <a:ln w="12700">
+            <a:solidFill>
+              <a:srgbClr val="2E5496"/>
+            </a:solidFill>
+          </a:ln>
+          <a:effectLst/>
+        </p:spPr>
+        <p:style>
+          <a:lnRef idx="1">
+            <a:schemeClr val="accent1"/>
+          </a:lnRef>
+          <a:fillRef idx="3">
+            <a:schemeClr val="accent1"/>
+          </a:fillRef>
+          <a:effectRef idx="2">
+            <a:schemeClr val="accent1"/>
+          </a:effectRef>
+          <a:fontRef idx="minor">
+            <a:schemeClr val="lt1"/>
+          </a:fontRef>
+        </p:style>
+        <p:txBody>
+          <a:bodyPr rtlCol="0" anchor="ctr"/>
+          <a:lstStyle/>
+          <a:p>
+            <a:pPr algn="ctr"/>
+          </a:p>
+        </p:txBody>
+      </p:sp>
+      <p:sp>
+        <p:nvSpPr>
+          <p:cNvPr id="11" name="TextBox 10"/>
+          <p:cNvSpPr txBox="1"/>
+          <p:nvPr/>
+        </p:nvSpPr>
+        <p:spPr>
+          <a:xfrm>
+            <a:off x="3429000" y="1856232"/>
+            <a:ext cx="2651760" cy="640080"/>
+          </a:xfrm>
+          <a:prstGeom prst="rect">
+            <a:avLst/>
+          </a:prstGeom>
+          <a:noFill/>
+        </p:spPr>
+        <p:txBody>
+          <a:bodyPr wrap="square" anchor="ctr">
+            <a:spAutoFit/>
+          </a:bodyPr>
+          <a:lstStyle/>
+          <a:p>
+            <a:pPr algn="ctr"/>
+            <a:r>
+              <a:rPr sz="3000" b="1">
+                <a:solidFill>
+                  <a:srgbClr val="1F3864"/>
+                </a:solidFill>
+                <a:latin typeface="Calibri"/>
+              </a:rPr>
+              <a:t>4,09/5</a:t>
+            </a:r>
+          </a:p>
+        </p:txBody>
+      </p:sp>
+      <p:sp>
+        <p:nvSpPr>
+          <p:cNvPr id="12" name="TextBox 11"/>
+          <p:cNvSpPr txBox="1"/>
+          <p:nvPr/>
+        </p:nvSpPr>
+        <p:spPr>
+          <a:xfrm>
+            <a:off x="3429000" y="2560320"/>
+            <a:ext cx="2651760" cy="411480"/>
+          </a:xfrm>
+          <a:prstGeom prst="rect">
+            <a:avLst/>
+          </a:prstGeom>
+          <a:noFill/>
+        </p:spPr>
+        <p:txBody>
+          <a:bodyPr wrap="square" anchor="t">
+            <a:spAutoFit/>
+          </a:bodyPr>
+          <a:lstStyle/>
+          <a:p>
+            <a:pPr algn="ctr"/>
+            <a:r>
+              <a:rPr sz="1200" b="0">
+                <a:solidFill>
+                  <a:srgbClr val="595959"/>
+                </a:solidFill>
+                <a:latin typeface="Calibri"/>
+              </a:rPr>
+              <a:t>nota média</a:t>
+            </a:r>
+          </a:p>
+        </p:txBody>
+      </p:sp>
+      <p:sp>
+        <p:nvSpPr>
+          <p:cNvPr id="13" name="Rectangle 12"/>
+          <p:cNvSpPr/>
+          <p:nvPr/>
+        </p:nvSpPr>
+        <p:spPr>
+          <a:xfrm>
+            <a:off x="6217920" y="1691640"/>
+            <a:ext cx="2651760" cy="1371600"/>
+          </a:xfrm>
+          <a:prstGeom prst="rect">
+            <a:avLst/>
+          </a:prstGeom>
+          <a:solidFill>
+            <a:srgbClr val="FFFFFF"/>
+          </a:solidFill>
+          <a:ln w="12700">
+            <a:solidFill>
+              <a:srgbClr val="2E5496"/>
+            </a:solidFill>
+          </a:ln>
+          <a:effectLst/>
+        </p:spPr>
+        <p:style>
+          <a:lnRef idx="1">
+            <a:schemeClr val="accent1"/>
+          </a:lnRef>
+          <a:fillRef idx="3">
+            <a:schemeClr val="accent1"/>
+          </a:fillRef>
+          <a:effectRef idx="2">
+            <a:schemeClr val="accent1"/>
+          </a:effectRef>
+          <a:fontRef idx="minor">
+            <a:schemeClr val="lt1"/>
+          </a:fontRef>
+        </p:style>
+        <p:txBody>
+          <a:bodyPr rtlCol="0" anchor="ctr"/>
+          <a:lstStyle/>
+          <a:p>
+            <a:pPr algn="ctr"/>
+          </a:p>
+        </p:txBody>
+      </p:sp>
+      <p:sp>
+        <p:nvSpPr>
+          <p:cNvPr id="14" name="TextBox 13"/>
+          <p:cNvSpPr txBox="1"/>
+          <p:nvPr/>
+        </p:nvSpPr>
+        <p:spPr>
+          <a:xfrm>
+            <a:off x="6217920" y="1856232"/>
+            <a:ext cx="2651760" cy="640080"/>
+          </a:xfrm>
+          <a:prstGeom prst="rect">
+            <a:avLst/>
+          </a:prstGeom>
+          <a:noFill/>
+        </p:spPr>
+        <p:txBody>
+          <a:bodyPr wrap="square" anchor="ctr">
+            <a:spAutoFit/>
+          </a:bodyPr>
+          <a:lstStyle/>
+          <a:p>
+            <a:pPr algn="ctr"/>
+            <a:r>
+              <a:rPr sz="3000" b="1">
+                <a:solidFill>
+                  <a:srgbClr val="1F3864"/>
+                </a:solidFill>
+                <a:latin typeface="Calibri"/>
+              </a:rPr>
+              <a:t>14,7%</a:t>
+            </a:r>
+          </a:p>
+        </p:txBody>
+      </p:sp>
+      <p:sp>
+        <p:nvSpPr>
+          <p:cNvPr id="15" name="TextBox 14"/>
+          <p:cNvSpPr txBox="1"/>
+          <p:nvPr/>
+        </p:nvSpPr>
+        <p:spPr>
+          <a:xfrm>
+            <a:off x="6217920" y="2560320"/>
+            <a:ext cx="2651760" cy="411480"/>
+          </a:xfrm>
+          <a:prstGeom prst="rect">
+            <a:avLst/>
+          </a:prstGeom>
+          <a:noFill/>
+        </p:spPr>
+        <p:txBody>
+          <a:bodyPr wrap="square" anchor="t">
+            <a:spAutoFit/>
+          </a:bodyPr>
+          <a:lstStyle/>
+          <a:p>
+            <a:pPr algn="ctr"/>
+            <a:r>
+              <a:rPr sz="1200" b="0">
+                <a:solidFill>
+                  <a:srgbClr val="595959"/>
+                </a:solidFill>
+                <a:latin typeface="Calibri"/>
+              </a:rPr>
+              <a:t>insatisfeitos</a:t>
+            </a:r>
+          </a:p>
+        </p:txBody>
+      </p:sp>
+      <p:graphicFrame>
+        <p:nvGraphicFramePr>
+          <p:cNvPr id="16" name="Chart 15"/>
+          <p:cNvGraphicFramePr>
+            <a:graphicFrameLocks noGrp="1"/>
+          </p:cNvGraphicFramePr>
+          <p:nvPr/>
+        </p:nvGraphicFramePr>
+        <p:xfrm>
+          <a:off x="640080" y="3291840"/>
+          <a:ext cx="6035040" cy="3108960"/>
+        </p:xfrm>
+        <a:graphic>
+          <a:graphicData uri="http://schemas.openxmlformats.org/drawingml/2006/chart">
+            <c:chart xmlns:c="http://schemas.openxmlformats.org/drawingml/2006/chart" r:id="rId2"/>
+          </a:graphicData>
+        </a:graphic>
+      </p:graphicFrame>
+      <p:sp>
+        <p:nvSpPr>
+          <p:cNvPr id="17" name="TextBox 16"/>
+          <p:cNvSpPr txBox="1"/>
+          <p:nvPr/>
+        </p:nvSpPr>
+        <p:spPr>
+          <a:xfrm>
+            <a:off x="6949440" y="3383280"/>
+            <a:ext cx="4754880" cy="2926080"/>
           </a:xfrm>
           <a:prstGeom prst="rect">
             <a:avLst/>
@@ -5781,97 +6148,65 @@
           <a:p>
             <a:pPr>
               <a:spcAft>
-                <a:spcPts val="1100"/>
+                <a:spcPts val="1000"/>
               </a:spcAft>
             </a:pPr>
             <a:r>
-              <a:rPr sz="1700" b="0">
+              <a:rPr sz="1500" b="0">
                 <a:solidFill>
                   <a:srgbClr val="595959"/>
                 </a:solidFill>
                 <a:latin typeface="Calibri"/>
               </a:rPr>
-              <a:t>•  **Repositório:** github.com/lukasrocharr/ETL-ECOMMERCE (público, com README).</a:t>
+              <a:t>•  **Insight:** receita concentrada em poucos sellers de SP.</a:t>
             </a:r>
           </a:p>
           <a:p>
             <a:pPr>
               <a:spcAft>
-                <a:spcPts val="1100"/>
+                <a:spcPts val="1000"/>
               </a:spcAft>
             </a:pPr>
             <a:r>
-              <a:rPr sz="1700" b="0">
+              <a:rPr sz="1500" b="0">
                 <a:solidFill>
                   <a:srgbClr val="595959"/>
                 </a:solidFill>
                 <a:latin typeface="Calibri"/>
               </a:rPr>
-              <a:t>•  **Estrutura de pastas:** sql/ (DDL, ETL, objetos), analise_olist/ (carga + 10 perguntas), docs/.</a:t>
+              <a:t>•  **Satisfação:** boa média (4,09), mas 14,7% dão nota 1-2.</a:t>
+            </a:r>
+          </a:p>
+          <a:p>
+            <a:pPr lvl="1">
+              <a:spcAft>
+                <a:spcPts val="1000"/>
+              </a:spcAft>
+            </a:pPr>
+            <a:r>
+              <a:rPr sz="1300" b="0">
+                <a:solidFill>
+                  <a:srgbClr val="595959"/>
+                </a:solidFill>
+                <a:latin typeface="Calibri"/>
+              </a:rPr>
+              <a:t>–  11,5% dão nota 1 — cauda de insatisfação relevante.</a:t>
             </a:r>
           </a:p>
           <a:p>
             <a:pPr>
               <a:spcAft>
-                <a:spcPts val="1100"/>
+                <a:spcPts val="1000"/>
               </a:spcAft>
             </a:pPr>
             <a:r>
-              <a:rPr sz="1700" b="0">
+              <a:rPr sz="1500" b="0">
                 <a:solidFill>
                   <a:srgbClr val="595959"/>
                 </a:solidFill>
                 <a:latin typeface="Calibri"/>
               </a:rPr>
-              <a:t>•  **Scripts:** 00_setup_e_carga.sql (carga) e 01_perguntas.sql (as 10 análises).</a:t>
-            </a:r>
-          </a:p>
-          <a:p>
-            <a:pPr>
-              <a:spcAft>
-                <a:spcPts val="1100"/>
-              </a:spcAft>
-            </a:pPr>
-            <a:r>
-              <a:rPr sz="1700" b="0">
-                <a:solidFill>
-                  <a:srgbClr val="595959"/>
-                </a:solidFill>
-                <a:latin typeface="Calibri"/>
-              </a:rPr>
-              <a:t>•  **Reprodutibilidade:** ambiente em Docker + scripts idempotentes = qualquer membro reproduz.</a:t>
-            </a:r>
-          </a:p>
-          <a:p>
-            <a:pPr>
-              <a:spcAft>
-                <a:spcPts val="1100"/>
-              </a:spcAft>
-            </a:pPr>
-            <a:r>
-              <a:rPr sz="1700" b="0">
-                <a:solidFill>
-                  <a:srgbClr val="595959"/>
-                </a:solidFill>
-                <a:latin typeface="Calibri"/>
-              </a:rPr>
-              <a:t>•  **Versionamento:** histórico de commits documentando a evolução do projeto.</a:t>
-            </a:r>
-          </a:p>
-          <a:p>
-            <a:pPr>
-              <a:spcAft>
-                <a:spcPts val="1100"/>
-              </a:spcAft>
-            </a:pPr>
-            <a:r>
-              <a:rPr sz="1700" b="0">
-                <a:solidFill>
-                  <a:srgbClr val="595959"/>
-                </a:solidFill>
-                <a:latin typeface="Calibri"/>
-              </a:rPr>
-              <a:t>•  **Gestão:** quadro Kanban (GitHub Projects/Trello) — [inserir print do board].</a:t>
+              <a:t>•  **Ação:** plano de qualidade para sellers e SAC proativo.</a:t>
             </a:r>
           </a:p>
         </p:txBody>
@@ -6012,7 +6347,7 @@
                 </a:solidFill>
                 <a:latin typeface="Calibri"/>
               </a:rPr>
-              <a:t>Etapa 6 — Encerramento</a:t>
+              <a:t>Etapa 5 — Gestão e Governança</a:t>
             </a:r>
           </a:p>
         </p:txBody>
@@ -6047,7 +6382,7 @@
                 </a:solidFill>
                 <a:latin typeface="Calibri"/>
               </a:rPr>
-              <a:t>Conclusão e Próximos Passos</a:t>
+              <a:t>Organização, Governança e Git</a:t>
             </a:r>
           </a:p>
         </p:txBody>
@@ -6105,7 +6440,7 @@
         <p:spPr>
           <a:xfrm>
             <a:off x="640080" y="1737360"/>
-            <a:ext cx="6126480" cy="4572000"/>
+            <a:ext cx="10972800" cy="4572000"/>
           </a:xfrm>
           <a:prstGeom prst="rect">
             <a:avLst/>
@@ -6120,168 +6455,97 @@
           <a:p>
             <a:pPr>
               <a:spcAft>
-                <a:spcPts val="800"/>
+                <a:spcPts val="1100"/>
               </a:spcAft>
             </a:pPr>
             <a:r>
-              <a:rPr sz="1600" b="1">
+              <a:rPr sz="1700" b="0">
                 <a:solidFill>
                   <a:srgbClr val="595959"/>
                 </a:solidFill>
                 <a:latin typeface="Calibri"/>
               </a:rPr>
-              <a:t>•  Principais conclusões:</a:t>
-            </a:r>
-          </a:p>
-          <a:p>
-            <a:pPr lvl="1">
+              <a:t>•  **Repositório:** github.com/lukasrocharr/ETL-ECOMMERCE (público, com README).</a:t>
+            </a:r>
+          </a:p>
+          <a:p>
+            <a:pPr>
               <a:spcAft>
-                <a:spcPts val="800"/>
+                <a:spcPts val="1100"/>
               </a:spcAft>
             </a:pPr>
             <a:r>
-              <a:rPr sz="1400" b="0">
+              <a:rPr sz="1700" b="0">
                 <a:solidFill>
                   <a:srgbClr val="595959"/>
                 </a:solidFill>
                 <a:latin typeface="Calibri"/>
               </a:rPr>
-              <a:t>–  Crédito domina; logística forte (93% no prazo).</a:t>
-            </a:r>
-          </a:p>
-          <a:p>
-            <a:pPr lvl="1">
+              <a:t>•  **Estrutura de pastas:** sql/ (DDL, ETL, objetos), analise_olist/ (carga + 10 perguntas), docs/.</a:t>
+            </a:r>
+          </a:p>
+          <a:p>
+            <a:pPr>
               <a:spcAft>
-                <a:spcPts val="800"/>
+                <a:spcPts val="1100"/>
               </a:spcAft>
             </a:pPr>
             <a:r>
-              <a:rPr sz="1400" b="0">
+              <a:rPr sz="1700" b="0">
                 <a:solidFill>
                   <a:srgbClr val="595959"/>
                 </a:solidFill>
                 <a:latin typeface="Calibri"/>
               </a:rPr>
-              <a:t>–  Demanda concentrada no Sudeste e em datas de pico.</a:t>
-            </a:r>
-          </a:p>
-          <a:p>
-            <a:pPr lvl="1">
+              <a:t>•  **Scripts:** 00_setup_e_carga.sql (carga) e 01_perguntas.sql (as 10 análises).</a:t>
+            </a:r>
+          </a:p>
+          <a:p>
+            <a:pPr>
               <a:spcAft>
-                <a:spcPts val="800"/>
+                <a:spcPts val="1100"/>
               </a:spcAft>
             </a:pPr>
             <a:r>
-              <a:rPr sz="1400" b="0">
+              <a:rPr sz="1700" b="0">
                 <a:solidFill>
                   <a:srgbClr val="595959"/>
                 </a:solidFill>
                 <a:latin typeface="Calibri"/>
               </a:rPr>
-              <a:t>–  Recompra baixíssima (3,1%) e 14,7% de insatisfeitos.</a:t>
-            </a:r>
-          </a:p>
-        </p:txBody>
-      </p:sp>
-      <p:sp>
-        <p:nvSpPr>
-          <p:cNvPr id="8" name="TextBox 7"/>
-          <p:cNvSpPr txBox="1"/>
-          <p:nvPr/>
-        </p:nvSpPr>
-        <p:spPr>
-          <a:xfrm>
-            <a:off x="6766560" y="1737360"/>
-            <a:ext cx="4937760" cy="4572000"/>
-          </a:xfrm>
-          <a:prstGeom prst="rect">
-            <a:avLst/>
-          </a:prstGeom>
-          <a:noFill/>
-        </p:spPr>
-        <p:txBody>
-          <a:bodyPr wrap="square">
-            <a:spAutoFit/>
-          </a:bodyPr>
-          <a:lstStyle/>
+              <a:t>•  **Reprodutibilidade:** ambiente em Docker + scripts idempotentes = qualquer membro reproduz.</a:t>
+            </a:r>
+          </a:p>
           <a:p>
             <a:pPr>
               <a:spcAft>
-                <a:spcPts val="800"/>
+                <a:spcPts val="1100"/>
               </a:spcAft>
             </a:pPr>
             <a:r>
-              <a:rPr sz="1600" b="1">
+              <a:rPr sz="1700" b="0">
                 <a:solidFill>
                   <a:srgbClr val="595959"/>
                 </a:solidFill>
                 <a:latin typeface="Calibri"/>
               </a:rPr>
-              <a:t>•  Próximos passos:</a:t>
-            </a:r>
-          </a:p>
-          <a:p>
-            <a:pPr lvl="1">
+              <a:t>•  **Versionamento:** histórico de commits documentando a evolução do projeto.</a:t>
+            </a:r>
+          </a:p>
+          <a:p>
+            <a:pPr>
               <a:spcAft>
-                <a:spcPts val="800"/>
+                <a:spcPts val="1100"/>
               </a:spcAft>
             </a:pPr>
             <a:r>
-              <a:rPr sz="1400" b="0">
+              <a:rPr sz="1700" b="0">
                 <a:solidFill>
                   <a:srgbClr val="595959"/>
                 </a:solidFill>
                 <a:latin typeface="Calibri"/>
               </a:rPr>
-              <a:t>–  Modelar um Data Warehouse estrela (fato vendas).</a:t>
-            </a:r>
-          </a:p>
-          <a:p>
-            <a:pPr lvl="1">
-              <a:spcAft>
-                <a:spcPts val="800"/>
-              </a:spcAft>
-            </a:pPr>
-            <a:r>
-              <a:rPr sz="1400" b="0">
-                <a:solidFill>
-                  <a:srgbClr val="595959"/>
-                </a:solidFill>
-                <a:latin typeface="Calibri"/>
-              </a:rPr>
-              <a:t>–  Conectar Dashboard de BI (Power BI/Metabase).</a:t>
-            </a:r>
-          </a:p>
-          <a:p>
-            <a:pPr lvl="1">
-              <a:spcAft>
-                <a:spcPts val="800"/>
-              </a:spcAft>
-            </a:pPr>
-            <a:r>
-              <a:rPr sz="1400" b="0">
-                <a:solidFill>
-                  <a:srgbClr val="595959"/>
-                </a:solidFill>
-                <a:latin typeface="Calibri"/>
-              </a:rPr>
-              <a:t>–  Programa de fidelização para elevar a recompra.</a:t>
-            </a:r>
-          </a:p>
-          <a:p>
-            <a:pPr lvl="1">
-              <a:spcAft>
-                <a:spcPts val="800"/>
-              </a:spcAft>
-            </a:pPr>
-            <a:r>
-              <a:rPr sz="1400" b="0">
-                <a:solidFill>
-                  <a:srgbClr val="595959"/>
-                </a:solidFill>
-                <a:latin typeface="Calibri"/>
-              </a:rPr>
-              <a:t>–  Painel de qualidade de sellers e satisfação.</a:t>
+              <a:t>•  **Gestão:** quadro Kanban (GitHub Projects/Trello) — [inserir print do board].</a:t>
             </a:r>
           </a:p>
         </p:txBody>
@@ -6357,6 +6621,416 @@
         <p:spPr>
           <a:xfrm>
             <a:off x="0" y="0"/>
+            <a:ext cx="12191695" cy="164592"/>
+          </a:xfrm>
+          <a:prstGeom prst="rect">
+            <a:avLst/>
+          </a:prstGeom>
+          <a:solidFill>
+            <a:srgbClr val="ED7D31"/>
+          </a:solidFill>
+          <a:ln>
+            <a:noFill/>
+          </a:ln>
+          <a:effectLst/>
+        </p:spPr>
+        <p:style>
+          <a:lnRef idx="1">
+            <a:schemeClr val="accent1"/>
+          </a:lnRef>
+          <a:fillRef idx="3">
+            <a:schemeClr val="accent1"/>
+          </a:fillRef>
+          <a:effectRef idx="2">
+            <a:schemeClr val="accent1"/>
+          </a:effectRef>
+          <a:fontRef idx="minor">
+            <a:schemeClr val="lt1"/>
+          </a:fontRef>
+        </p:style>
+        <p:txBody>
+          <a:bodyPr rtlCol="0" anchor="ctr"/>
+          <a:lstStyle/>
+          <a:p>
+            <a:pPr algn="ctr"/>
+          </a:p>
+        </p:txBody>
+      </p:sp>
+      <p:sp>
+        <p:nvSpPr>
+          <p:cNvPr id="4" name="TextBox 3"/>
+          <p:cNvSpPr txBox="1"/>
+          <p:nvPr/>
+        </p:nvSpPr>
+        <p:spPr>
+          <a:xfrm>
+            <a:off x="548640" y="320040"/>
+            <a:ext cx="10972800" cy="365760"/>
+          </a:xfrm>
+          <a:prstGeom prst="rect">
+            <a:avLst/>
+          </a:prstGeom>
+          <a:noFill/>
+        </p:spPr>
+        <p:txBody>
+          <a:bodyPr wrap="square" anchor="t">
+            <a:spAutoFit/>
+          </a:bodyPr>
+          <a:lstStyle/>
+          <a:p>
+            <a:pPr algn="l"/>
+            <a:r>
+              <a:rPr sz="1300" b="1">
+                <a:solidFill>
+                  <a:srgbClr val="ED7D31"/>
+                </a:solidFill>
+                <a:latin typeface="Calibri"/>
+              </a:rPr>
+              <a:t>Etapa 6 — Encerramento</a:t>
+            </a:r>
+          </a:p>
+        </p:txBody>
+      </p:sp>
+      <p:sp>
+        <p:nvSpPr>
+          <p:cNvPr id="5" name="TextBox 4"/>
+          <p:cNvSpPr txBox="1"/>
+          <p:nvPr/>
+        </p:nvSpPr>
+        <p:spPr>
+          <a:xfrm>
+            <a:off x="548640" y="640080"/>
+            <a:ext cx="11064240" cy="822960"/>
+          </a:xfrm>
+          <a:prstGeom prst="rect">
+            <a:avLst/>
+          </a:prstGeom>
+          <a:noFill/>
+        </p:spPr>
+        <p:txBody>
+          <a:bodyPr wrap="square" anchor="t">
+            <a:spAutoFit/>
+          </a:bodyPr>
+          <a:lstStyle/>
+          <a:p>
+            <a:pPr algn="l"/>
+            <a:r>
+              <a:rPr sz="2800" b="1">
+                <a:solidFill>
+                  <a:srgbClr val="1F3864"/>
+                </a:solidFill>
+                <a:latin typeface="Calibri"/>
+              </a:rPr>
+              <a:t>Conclusão e Próximos Passos</a:t>
+            </a:r>
+          </a:p>
+        </p:txBody>
+      </p:sp>
+      <p:sp>
+        <p:nvSpPr>
+          <p:cNvPr id="6" name="Rectangle 5"/>
+          <p:cNvSpPr/>
+          <p:nvPr/>
+        </p:nvSpPr>
+        <p:spPr>
+          <a:xfrm>
+            <a:off x="548640" y="1417320"/>
+            <a:ext cx="11064240" cy="25400"/>
+          </a:xfrm>
+          <a:prstGeom prst="rect">
+            <a:avLst/>
+          </a:prstGeom>
+          <a:solidFill>
+            <a:srgbClr val="2E5496"/>
+          </a:solidFill>
+          <a:ln>
+            <a:noFill/>
+          </a:ln>
+          <a:effectLst/>
+        </p:spPr>
+        <p:style>
+          <a:lnRef idx="1">
+            <a:schemeClr val="accent1"/>
+          </a:lnRef>
+          <a:fillRef idx="3">
+            <a:schemeClr val="accent1"/>
+          </a:fillRef>
+          <a:effectRef idx="2">
+            <a:schemeClr val="accent1"/>
+          </a:effectRef>
+          <a:fontRef idx="minor">
+            <a:schemeClr val="lt1"/>
+          </a:fontRef>
+        </p:style>
+        <p:txBody>
+          <a:bodyPr rtlCol="0" anchor="ctr"/>
+          <a:lstStyle/>
+          <a:p>
+            <a:pPr algn="ctr"/>
+          </a:p>
+        </p:txBody>
+      </p:sp>
+      <p:sp>
+        <p:nvSpPr>
+          <p:cNvPr id="7" name="TextBox 6"/>
+          <p:cNvSpPr txBox="1"/>
+          <p:nvPr/>
+        </p:nvSpPr>
+        <p:spPr>
+          <a:xfrm>
+            <a:off x="640080" y="1737360"/>
+            <a:ext cx="6126480" cy="4572000"/>
+          </a:xfrm>
+          <a:prstGeom prst="rect">
+            <a:avLst/>
+          </a:prstGeom>
+          <a:noFill/>
+        </p:spPr>
+        <p:txBody>
+          <a:bodyPr wrap="square">
+            <a:spAutoFit/>
+          </a:bodyPr>
+          <a:lstStyle/>
+          <a:p>
+            <a:pPr>
+              <a:spcAft>
+                <a:spcPts val="800"/>
+              </a:spcAft>
+            </a:pPr>
+            <a:r>
+              <a:rPr sz="1600" b="1">
+                <a:solidFill>
+                  <a:srgbClr val="595959"/>
+                </a:solidFill>
+                <a:latin typeface="Calibri"/>
+              </a:rPr>
+              <a:t>•  Principais conclusões:</a:t>
+            </a:r>
+          </a:p>
+          <a:p>
+            <a:pPr lvl="1">
+              <a:spcAft>
+                <a:spcPts val="800"/>
+              </a:spcAft>
+            </a:pPr>
+            <a:r>
+              <a:rPr sz="1400" b="0">
+                <a:solidFill>
+                  <a:srgbClr val="595959"/>
+                </a:solidFill>
+                <a:latin typeface="Calibri"/>
+              </a:rPr>
+              <a:t>–  Crédito domina; logística forte (93% no prazo).</a:t>
+            </a:r>
+          </a:p>
+          <a:p>
+            <a:pPr lvl="1">
+              <a:spcAft>
+                <a:spcPts val="800"/>
+              </a:spcAft>
+            </a:pPr>
+            <a:r>
+              <a:rPr sz="1400" b="0">
+                <a:solidFill>
+                  <a:srgbClr val="595959"/>
+                </a:solidFill>
+                <a:latin typeface="Calibri"/>
+              </a:rPr>
+              <a:t>–  Demanda concentrada no Sudeste e em datas de pico.</a:t>
+            </a:r>
+          </a:p>
+          <a:p>
+            <a:pPr lvl="1">
+              <a:spcAft>
+                <a:spcPts val="800"/>
+              </a:spcAft>
+            </a:pPr>
+            <a:r>
+              <a:rPr sz="1400" b="0">
+                <a:solidFill>
+                  <a:srgbClr val="595959"/>
+                </a:solidFill>
+                <a:latin typeface="Calibri"/>
+              </a:rPr>
+              <a:t>–  Recompra baixíssima (3,1%) e 14,7% de insatisfeitos.</a:t>
+            </a:r>
+          </a:p>
+        </p:txBody>
+      </p:sp>
+      <p:sp>
+        <p:nvSpPr>
+          <p:cNvPr id="8" name="TextBox 7"/>
+          <p:cNvSpPr txBox="1"/>
+          <p:nvPr/>
+        </p:nvSpPr>
+        <p:spPr>
+          <a:xfrm>
+            <a:off x="6766560" y="1737360"/>
+            <a:ext cx="4937760" cy="4572000"/>
+          </a:xfrm>
+          <a:prstGeom prst="rect">
+            <a:avLst/>
+          </a:prstGeom>
+          <a:noFill/>
+        </p:spPr>
+        <p:txBody>
+          <a:bodyPr wrap="square">
+            <a:spAutoFit/>
+          </a:bodyPr>
+          <a:lstStyle/>
+          <a:p>
+            <a:pPr>
+              <a:spcAft>
+                <a:spcPts val="800"/>
+              </a:spcAft>
+            </a:pPr>
+            <a:r>
+              <a:rPr sz="1600" b="1">
+                <a:solidFill>
+                  <a:srgbClr val="595959"/>
+                </a:solidFill>
+                <a:latin typeface="Calibri"/>
+              </a:rPr>
+              <a:t>•  Próximos passos:</a:t>
+            </a:r>
+          </a:p>
+          <a:p>
+            <a:pPr lvl="1">
+              <a:spcAft>
+                <a:spcPts val="800"/>
+              </a:spcAft>
+            </a:pPr>
+            <a:r>
+              <a:rPr sz="1400" b="0">
+                <a:solidFill>
+                  <a:srgbClr val="595959"/>
+                </a:solidFill>
+                <a:latin typeface="Calibri"/>
+              </a:rPr>
+              <a:t>–  Modelar um Data Warehouse estrela (fato vendas).</a:t>
+            </a:r>
+          </a:p>
+          <a:p>
+            <a:pPr lvl="1">
+              <a:spcAft>
+                <a:spcPts val="800"/>
+              </a:spcAft>
+            </a:pPr>
+            <a:r>
+              <a:rPr sz="1400" b="0">
+                <a:solidFill>
+                  <a:srgbClr val="595959"/>
+                </a:solidFill>
+                <a:latin typeface="Calibri"/>
+              </a:rPr>
+              <a:t>–  Conectar Dashboard de BI (Power BI/Metabase).</a:t>
+            </a:r>
+          </a:p>
+          <a:p>
+            <a:pPr lvl="1">
+              <a:spcAft>
+                <a:spcPts val="800"/>
+              </a:spcAft>
+            </a:pPr>
+            <a:r>
+              <a:rPr sz="1400" b="0">
+                <a:solidFill>
+                  <a:srgbClr val="595959"/>
+                </a:solidFill>
+                <a:latin typeface="Calibri"/>
+              </a:rPr>
+              <a:t>–  Programa de fidelização para elevar a recompra.</a:t>
+            </a:r>
+          </a:p>
+          <a:p>
+            <a:pPr lvl="1">
+              <a:spcAft>
+                <a:spcPts val="800"/>
+              </a:spcAft>
+            </a:pPr>
+            <a:r>
+              <a:rPr sz="1400" b="0">
+                <a:solidFill>
+                  <a:srgbClr val="595959"/>
+                </a:solidFill>
+                <a:latin typeface="Calibri"/>
+              </a:rPr>
+              <a:t>–  Painel de qualidade de sellers e satisfação.</a:t>
+            </a:r>
+          </a:p>
+        </p:txBody>
+      </p:sp>
+    </p:spTree>
+  </p:cSld>
+  <p:clrMapOvr>
+    <a:masterClrMapping/>
+  </p:clrMapOvr>
+</p:sld>
+</file>
+
+<file path=ppt/slides/slide15.xml><?xml version="1.0" encoding="utf-8"?>
+<p:sld xmlns:a="http://schemas.openxmlformats.org/drawingml/2006/main" xmlns:p="http://schemas.openxmlformats.org/presentationml/2006/main" xmlns:r="http://schemas.openxmlformats.org/officeDocument/2006/relationships">
+  <p:cSld>
+    <p:spTree>
+      <p:nvGrpSpPr>
+        <p:cNvPr id="1" name=""/>
+        <p:cNvGrpSpPr/>
+        <p:nvPr/>
+      </p:nvGrpSpPr>
+      <p:grpSpPr/>
+      <p:sp>
+        <p:nvSpPr>
+          <p:cNvPr id="2" name="Rectangle 1"/>
+          <p:cNvSpPr/>
+          <p:nvPr/>
+        </p:nvSpPr>
+        <p:spPr>
+          <a:xfrm>
+            <a:off x="0" y="0"/>
+            <a:ext cx="12191695" cy="6858000"/>
+          </a:xfrm>
+          <a:prstGeom prst="rect">
+            <a:avLst/>
+          </a:prstGeom>
+          <a:solidFill>
+            <a:srgbClr val="F2F5FA"/>
+          </a:solidFill>
+          <a:ln>
+            <a:noFill/>
+          </a:ln>
+          <a:effectLst/>
+        </p:spPr>
+        <p:style>
+          <a:lnRef idx="1">
+            <a:schemeClr val="accent1"/>
+          </a:lnRef>
+          <a:fillRef idx="3">
+            <a:schemeClr val="accent1"/>
+          </a:fillRef>
+          <a:effectRef idx="2">
+            <a:schemeClr val="accent1"/>
+          </a:effectRef>
+          <a:fontRef idx="minor">
+            <a:schemeClr val="lt1"/>
+          </a:fontRef>
+        </p:style>
+        <p:txBody>
+          <a:bodyPr rtlCol="0" anchor="ctr"/>
+          <a:lstStyle/>
+          <a:p>
+            <a:pPr algn="ctr"/>
+          </a:p>
+        </p:txBody>
+      </p:sp>
+      <p:sp>
+        <p:nvSpPr>
+          <p:cNvPr id="3" name="Rectangle 2"/>
+          <p:cNvSpPr/>
+          <p:nvPr/>
+        </p:nvSpPr>
+        <p:spPr>
+          <a:xfrm>
+            <a:off x="0" y="0"/>
             <a:ext cx="12191695" cy="6858000"/>
           </a:xfrm>
           <a:prstGeom prst="rect">
@@ -7116,7 +7790,23 @@
                 </a:solidFill>
                 <a:latin typeface="Calibri"/>
               </a:rPr>
-              <a:t>•  **Volumetria:** mais de meio milhão de registros somando</a:t>
+              <a:t>•  **Modelo:** 8 CSV brutos → modelo estrela de **20 tabelas**.</a:t>
+            </a:r>
+          </a:p>
+          <a:p>
+            <a:pPr>
+              <a:spcAft>
+                <a:spcPts val="800"/>
+              </a:spcAft>
+            </a:pPr>
+            <a:r>
+              <a:rPr sz="1600" b="0">
+                <a:solidFill>
+                  <a:srgbClr val="595959"/>
+                </a:solidFill>
+                <a:latin typeface="Calibri"/>
+              </a:rPr>
+              <a:t>•  **Volumetria:** +500 mil registros; maior fato (itens de</a:t>
             </a:r>
           </a:p>
           <a:p>
@@ -7132,7 +7822,7 @@
                 </a:solidFill>
                 <a:latin typeface="Calibri"/>
               </a:rPr>
-              <a:t>–  as 8 tabelas (geolocation adicional ~1 milhão de linhas).</a:t>
+              <a:t>–  pedido) com 112.650 linhas.</a:t>
             </a:r>
           </a:p>
         </p:txBody>
@@ -7960,7 +8650,7 @@
                 </a:solidFill>
                 <a:latin typeface="Calibri"/>
               </a:rPr>
-              <a:t>Modelo de Dados e Decisões</a:t>
+              <a:t>Modelo Dimensional — 20 Tabelas (Estrela)</a:t>
             </a:r>
           </a:p>
         </p:txBody>
@@ -8011,14 +8701,112 @@
       </p:sp>
       <p:sp>
         <p:nvSpPr>
-          <p:cNvPr id="7" name="TextBox 6"/>
+          <p:cNvPr id="7" name="Rectangle 6"/>
+          <p:cNvSpPr/>
+          <p:nvPr/>
+        </p:nvSpPr>
+        <p:spPr>
+          <a:xfrm>
+            <a:off x="502920" y="1691640"/>
+            <a:ext cx="3794760" cy="411480"/>
+          </a:xfrm>
+          <a:prstGeom prst="rect">
+            <a:avLst/>
+          </a:prstGeom>
+          <a:solidFill>
+            <a:srgbClr val="595959"/>
+          </a:solidFill>
+          <a:ln>
+            <a:noFill/>
+          </a:ln>
+          <a:effectLst/>
+        </p:spPr>
+        <p:style>
+          <a:lnRef idx="1">
+            <a:schemeClr val="accent1"/>
+          </a:lnRef>
+          <a:fillRef idx="3">
+            <a:schemeClr val="accent1"/>
+          </a:fillRef>
+          <a:effectRef idx="2">
+            <a:schemeClr val="accent1"/>
+          </a:effectRef>
+          <a:fontRef idx="minor">
+            <a:schemeClr val="lt1"/>
+          </a:fontRef>
+        </p:style>
+        <p:txBody>
+          <a:bodyPr rtlCol="0" anchor="ctr"/>
+          <a:lstStyle/>
+          <a:p>
+            <a:pPr algn="ctr"/>
+            <a:r>
+              <a:rPr b="1" sz="1300">
+                <a:solidFill>
+                  <a:srgbClr val="FFFFFF"/>
+                </a:solidFill>
+              </a:rPr>
+              <a:t>STAGING (8)</a:t>
+            </a:r>
+          </a:p>
+        </p:txBody>
+      </p:sp>
+      <p:sp>
+        <p:nvSpPr>
+          <p:cNvPr id="8" name="Rectangle 7"/>
+          <p:cNvSpPr/>
+          <p:nvPr/>
+        </p:nvSpPr>
+        <p:spPr>
+          <a:xfrm>
+            <a:off x="502920" y="2130552"/>
+            <a:ext cx="3794760" cy="2715768"/>
+          </a:xfrm>
+          <a:prstGeom prst="rect">
+            <a:avLst/>
+          </a:prstGeom>
+          <a:solidFill>
+            <a:srgbClr val="FFFFFF"/>
+          </a:solidFill>
+          <a:ln w="19050">
+            <a:solidFill>
+              <a:srgbClr val="595959"/>
+            </a:solidFill>
+          </a:ln>
+          <a:effectLst/>
+        </p:spPr>
+        <p:style>
+          <a:lnRef idx="1">
+            <a:schemeClr val="accent1"/>
+          </a:lnRef>
+          <a:fillRef idx="3">
+            <a:schemeClr val="accent1"/>
+          </a:fillRef>
+          <a:effectRef idx="2">
+            <a:schemeClr val="accent1"/>
+          </a:effectRef>
+          <a:fontRef idx="minor">
+            <a:schemeClr val="lt1"/>
+          </a:fontRef>
+        </p:style>
+        <p:txBody>
+          <a:bodyPr rtlCol="0" anchor="ctr"/>
+          <a:lstStyle/>
+          <a:p>
+            <a:pPr algn="ctr"/>
+          </a:p>
+        </p:txBody>
+      </p:sp>
+      <p:sp>
+        <p:nvSpPr>
+          <p:cNvPr id="9" name="TextBox 8"/>
           <p:cNvSpPr txBox="1"/>
           <p:nvPr/>
         </p:nvSpPr>
         <p:spPr>
           <a:xfrm>
-            <a:off x="640080" y="1737360"/>
-            <a:ext cx="6126480" cy="4572000"/>
+            <a:off x="612648" y="2203704"/>
+            <a:ext cx="3575304" cy="2715768"/>
           </a:xfrm>
           <a:prstGeom prst="rect">
             <a:avLst/>
@@ -8033,159 +8821,187 @@
           <a:p>
             <a:pPr>
               <a:spcAft>
-                <a:spcPts val="800"/>
+                <a:spcPts val="400"/>
               </a:spcAft>
             </a:pPr>
             <a:r>
-              <a:rPr sz="1500" b="0">
+              <a:rPr sz="1150">
                 <a:solidFill>
                   <a:srgbClr val="595959"/>
                 </a:solidFill>
-                <a:latin typeface="Calibri"/>
-              </a:rPr>
-              <a:t>•  **Entidades centrais:** orders (pedidos) e order_items (itens).</a:t>
+              </a:rPr>
+              <a:t>•  raw_orders — 99.441</a:t>
             </a:r>
           </a:p>
           <a:p>
             <a:pPr>
               <a:spcAft>
-                <a:spcPts val="800"/>
+                <a:spcPts val="400"/>
               </a:spcAft>
             </a:pPr>
             <a:r>
-              <a:rPr sz="1500" b="0">
+              <a:rPr sz="1150">
                 <a:solidFill>
                   <a:srgbClr val="595959"/>
                 </a:solidFill>
-                <a:latin typeface="Calibri"/>
-              </a:rPr>
-              <a:t>•  **Dimensões:** products, sellers, customers, category_translation.</a:t>
+              </a:rPr>
+              <a:t>•  raw_order_items — 112.650</a:t>
             </a:r>
           </a:p>
           <a:p>
             <a:pPr>
               <a:spcAft>
-                <a:spcPts val="800"/>
+                <a:spcPts val="400"/>
               </a:spcAft>
             </a:pPr>
             <a:r>
-              <a:rPr sz="1500" b="0">
+              <a:rPr sz="1150">
                 <a:solidFill>
                   <a:srgbClr val="595959"/>
                 </a:solidFill>
-                <a:latin typeface="Calibri"/>
-              </a:rPr>
-              <a:t>•  **Eventos/transações:** payments, reviews.</a:t>
+              </a:rPr>
+              <a:t>•  raw_payments — 103.886</a:t>
             </a:r>
           </a:p>
           <a:p>
             <a:pPr>
               <a:spcAft>
-                <a:spcPts val="800"/>
+                <a:spcPts val="400"/>
               </a:spcAft>
             </a:pPr>
             <a:r>
-              <a:rPr sz="1500" b="0">
+              <a:rPr sz="1150">
                 <a:solidFill>
                   <a:srgbClr val="595959"/>
                 </a:solidFill>
-                <a:latin typeface="Calibri"/>
-              </a:rPr>
-              <a:t>•  **Tipos &amp; integridade:** carga em staging textual e conversão</a:t>
-            </a:r>
-          </a:p>
-          <a:p>
-            <a:pPr lvl="1">
+              </a:rPr>
+              <a:t>•  raw_reviews — 99.224</a:t>
+            </a:r>
+          </a:p>
+          <a:p>
+            <a:pPr>
               <a:spcAft>
-                <a:spcPts val="800"/>
+                <a:spcPts val="400"/>
               </a:spcAft>
             </a:pPr>
             <a:r>
-              <a:rPr sz="1300" b="0">
+              <a:rPr sz="1150">
                 <a:solidFill>
                   <a:srgbClr val="595959"/>
                 </a:solidFill>
-                <a:latin typeface="Calibri"/>
-              </a:rPr>
-              <a:t>–  segura com TRY_CONVERT (datas, decimais e inteiros).</a:t>
+              </a:rPr>
+              <a:t>•  raw_products — 32.951</a:t>
             </a:r>
           </a:p>
           <a:p>
             <a:pPr>
               <a:spcAft>
-                <a:spcPts val="800"/>
+                <a:spcPts val="400"/>
               </a:spcAft>
             </a:pPr>
             <a:r>
-              <a:rPr sz="1500" b="0">
+              <a:rPr sz="1150">
                 <a:solidFill>
                   <a:srgbClr val="595959"/>
                 </a:solidFill>
-                <a:latin typeface="Calibri"/>
-              </a:rPr>
-              <a:t>•  **Índices/chaves:** order_id e product_id conectam as tabelas;</a:t>
-            </a:r>
-          </a:p>
-          <a:p>
-            <a:pPr lvl="1">
+              </a:rPr>
+              <a:t>•  raw_customers — 99.441</a:t>
+            </a:r>
+          </a:p>
+          <a:p>
+            <a:pPr>
               <a:spcAft>
-                <a:spcPts val="800"/>
+                <a:spcPts val="400"/>
               </a:spcAft>
             </a:pPr>
             <a:r>
-              <a:rPr sz="1300" b="0">
+              <a:rPr sz="1150">
                 <a:solidFill>
                   <a:srgbClr val="595959"/>
                 </a:solidFill>
-                <a:latin typeface="Calibri"/>
-              </a:rPr>
-              <a:t>–  joins entre até 4 tabelas nas consultas analíticas.</a:t>
+              </a:rPr>
+              <a:t>•  raw_sellers — 3.095</a:t>
             </a:r>
           </a:p>
           <a:p>
             <a:pPr>
               <a:spcAft>
-                <a:spcPts val="800"/>
+                <a:spcPts val="400"/>
               </a:spcAft>
             </a:pPr>
             <a:r>
-              <a:rPr sz="1500" b="0">
+              <a:rPr sz="1150">
                 <a:solidFill>
                   <a:srgbClr val="595959"/>
                 </a:solidFill>
-                <a:latin typeface="Calibri"/>
-              </a:rPr>
-              <a:t>•  **Governança:** ambiente SQL Server 2022 isolado em Docker;</a:t>
-            </a:r>
-          </a:p>
-          <a:p>
-            <a:pPr lvl="1">
-              <a:spcAft>
-                <a:spcPts val="800"/>
-              </a:spcAft>
-            </a:pPr>
-            <a:r>
-              <a:rPr sz="1300" b="0">
-                <a:solidFill>
-                  <a:srgbClr val="595959"/>
-                </a:solidFill>
-                <a:latin typeface="Calibri"/>
-              </a:rPr>
-              <a:t>–  scripts versionados e reexecutáveis (idempotentes).</a:t>
-            </a:r>
-          </a:p>
-        </p:txBody>
-      </p:sp>
-      <p:sp>
-        <p:nvSpPr>
-          <p:cNvPr id="8" name="Rectangle 7"/>
+              </a:rPr>
+              <a:t>•  raw_cat_translation — 71</a:t>
+            </a:r>
+          </a:p>
+        </p:txBody>
+      </p:sp>
+      <p:sp>
+        <p:nvSpPr>
+          <p:cNvPr id="10" name="Rectangle 9"/>
           <p:cNvSpPr/>
           <p:nvPr/>
         </p:nvSpPr>
         <p:spPr>
           <a:xfrm>
-            <a:off x="7132320" y="1828800"/>
-            <a:ext cx="4389120" cy="3840480"/>
+            <a:off x="4434840" y="1691640"/>
+            <a:ext cx="3794760" cy="411480"/>
+          </a:xfrm>
+          <a:prstGeom prst="rect">
+            <a:avLst/>
+          </a:prstGeom>
+          <a:solidFill>
+            <a:srgbClr val="2E5496"/>
+          </a:solidFill>
+          <a:ln>
+            <a:noFill/>
+          </a:ln>
+          <a:effectLst/>
+        </p:spPr>
+        <p:style>
+          <a:lnRef idx="1">
+            <a:schemeClr val="accent1"/>
+          </a:lnRef>
+          <a:fillRef idx="3">
+            <a:schemeClr val="accent1"/>
+          </a:fillRef>
+          <a:effectRef idx="2">
+            <a:schemeClr val="accent1"/>
+          </a:effectRef>
+          <a:fontRef idx="minor">
+            <a:schemeClr val="lt1"/>
+          </a:fontRef>
+        </p:style>
+        <p:txBody>
+          <a:bodyPr rtlCol="0" anchor="ctr"/>
+          <a:lstStyle/>
+          <a:p>
+            <a:pPr algn="ctr"/>
+            <a:r>
+              <a:rPr b="1" sz="1300">
+                <a:solidFill>
+                  <a:srgbClr val="FFFFFF"/>
+                </a:solidFill>
+              </a:rPr>
+              <a:t>DIMENSÕES (8)</a:t>
+            </a:r>
+          </a:p>
+        </p:txBody>
+      </p:sp>
+      <p:sp>
+        <p:nvSpPr>
+          <p:cNvPr id="11" name="Rectangle 10"/>
+          <p:cNvSpPr/>
+          <p:nvPr/>
+        </p:nvSpPr>
+        <p:spPr>
+          <a:xfrm>
+            <a:off x="4434840" y="2130552"/>
+            <a:ext cx="3794760" cy="2715768"/>
           </a:xfrm>
           <a:prstGeom prst="rect">
             <a:avLst/>
@@ -8193,7 +9009,7 @@
           <a:solidFill>
             <a:srgbClr val="FFFFFF"/>
           </a:solidFill>
-          <a:ln>
+          <a:ln w="19050">
             <a:solidFill>
               <a:srgbClr val="2E5496"/>
             </a:solidFill>
@@ -8224,14 +9040,338 @@
       </p:sp>
       <p:sp>
         <p:nvSpPr>
-          <p:cNvPr id="9" name="TextBox 8"/>
+          <p:cNvPr id="12" name="TextBox 11"/>
           <p:cNvSpPr txBox="1"/>
           <p:nvPr/>
         </p:nvSpPr>
         <p:spPr>
           <a:xfrm>
-            <a:off x="7132320" y="1920240"/>
-            <a:ext cx="4389120" cy="457200"/>
+            <a:off x="4544568" y="2203704"/>
+            <a:ext cx="3575304" cy="2715768"/>
+          </a:xfrm>
+          <a:prstGeom prst="rect">
+            <a:avLst/>
+          </a:prstGeom>
+          <a:noFill/>
+        </p:spPr>
+        <p:txBody>
+          <a:bodyPr wrap="square">
+            <a:spAutoFit/>
+          </a:bodyPr>
+          <a:lstStyle/>
+          <a:p>
+            <a:pPr>
+              <a:spcAft>
+                <a:spcPts val="400"/>
+              </a:spcAft>
+            </a:pPr>
+            <a:r>
+              <a:rPr sz="1150">
+                <a:solidFill>
+                  <a:srgbClr val="595959"/>
+                </a:solidFill>
+              </a:rPr>
+              <a:t>•  dim_tempo — 1.096</a:t>
+            </a:r>
+          </a:p>
+          <a:p>
+            <a:pPr>
+              <a:spcAft>
+                <a:spcPts val="400"/>
+              </a:spcAft>
+            </a:pPr>
+            <a:r>
+              <a:rPr sz="1150">
+                <a:solidFill>
+                  <a:srgbClr val="595959"/>
+                </a:solidFill>
+              </a:rPr>
+              <a:t>•  dim_cliente — 96.096</a:t>
+            </a:r>
+          </a:p>
+          <a:p>
+            <a:pPr>
+              <a:spcAft>
+                <a:spcPts val="400"/>
+              </a:spcAft>
+            </a:pPr>
+            <a:r>
+              <a:rPr sz="1150">
+                <a:solidFill>
+                  <a:srgbClr val="595959"/>
+                </a:solidFill>
+              </a:rPr>
+              <a:t>•  dim_produto — 32.951</a:t>
+            </a:r>
+          </a:p>
+          <a:p>
+            <a:pPr>
+              <a:spcAft>
+                <a:spcPts val="400"/>
+              </a:spcAft>
+            </a:pPr>
+            <a:r>
+              <a:rPr sz="1150">
+                <a:solidFill>
+                  <a:srgbClr val="595959"/>
+                </a:solidFill>
+              </a:rPr>
+              <a:t>•  dim_categoria — 73</a:t>
+            </a:r>
+          </a:p>
+          <a:p>
+            <a:pPr>
+              <a:spcAft>
+                <a:spcPts val="400"/>
+              </a:spcAft>
+            </a:pPr>
+            <a:r>
+              <a:rPr sz="1150">
+                <a:solidFill>
+                  <a:srgbClr val="595959"/>
+                </a:solidFill>
+              </a:rPr>
+              <a:t>•  dim_vendedor — 3.095</a:t>
+            </a:r>
+          </a:p>
+          <a:p>
+            <a:pPr>
+              <a:spcAft>
+                <a:spcPts val="400"/>
+              </a:spcAft>
+            </a:pPr>
+            <a:r>
+              <a:rPr sz="1150">
+                <a:solidFill>
+                  <a:srgbClr val="595959"/>
+                </a:solidFill>
+              </a:rPr>
+              <a:t>•  dim_status_pedido — 8</a:t>
+            </a:r>
+          </a:p>
+          <a:p>
+            <a:pPr>
+              <a:spcAft>
+                <a:spcPts val="400"/>
+              </a:spcAft>
+            </a:pPr>
+            <a:r>
+              <a:rPr sz="1150">
+                <a:solidFill>
+                  <a:srgbClr val="595959"/>
+                </a:solidFill>
+              </a:rPr>
+              <a:t>•  dim_forma_pagamento — 5</a:t>
+            </a:r>
+          </a:p>
+          <a:p>
+            <a:pPr>
+              <a:spcAft>
+                <a:spcPts val="400"/>
+              </a:spcAft>
+            </a:pPr>
+            <a:r>
+              <a:rPr sz="1150">
+                <a:solidFill>
+                  <a:srgbClr val="595959"/>
+                </a:solidFill>
+              </a:rPr>
+              <a:t>•  dim_avaliacao — 5</a:t>
+            </a:r>
+          </a:p>
+        </p:txBody>
+      </p:sp>
+      <p:sp>
+        <p:nvSpPr>
+          <p:cNvPr id="13" name="Rectangle 12"/>
+          <p:cNvSpPr/>
+          <p:nvPr/>
+        </p:nvSpPr>
+        <p:spPr>
+          <a:xfrm>
+            <a:off x="8366760" y="1691640"/>
+            <a:ext cx="3291840" cy="411480"/>
+          </a:xfrm>
+          <a:prstGeom prst="rect">
+            <a:avLst/>
+          </a:prstGeom>
+          <a:solidFill>
+            <a:srgbClr val="ED7D31"/>
+          </a:solidFill>
+          <a:ln>
+            <a:noFill/>
+          </a:ln>
+          <a:effectLst/>
+        </p:spPr>
+        <p:style>
+          <a:lnRef idx="1">
+            <a:schemeClr val="accent1"/>
+          </a:lnRef>
+          <a:fillRef idx="3">
+            <a:schemeClr val="accent1"/>
+          </a:fillRef>
+          <a:effectRef idx="2">
+            <a:schemeClr val="accent1"/>
+          </a:effectRef>
+          <a:fontRef idx="minor">
+            <a:schemeClr val="lt1"/>
+          </a:fontRef>
+        </p:style>
+        <p:txBody>
+          <a:bodyPr rtlCol="0" anchor="ctr"/>
+          <a:lstStyle/>
+          <a:p>
+            <a:pPr algn="ctr"/>
+            <a:r>
+              <a:rPr b="1" sz="1300">
+                <a:solidFill>
+                  <a:srgbClr val="FFFFFF"/>
+                </a:solidFill>
+              </a:rPr>
+              <a:t>FATOS (4)</a:t>
+            </a:r>
+          </a:p>
+        </p:txBody>
+      </p:sp>
+      <p:sp>
+        <p:nvSpPr>
+          <p:cNvPr id="14" name="Rectangle 13"/>
+          <p:cNvSpPr/>
+          <p:nvPr/>
+        </p:nvSpPr>
+        <p:spPr>
+          <a:xfrm>
+            <a:off x="8366760" y="2130552"/>
+            <a:ext cx="3291840" cy="1472184"/>
+          </a:xfrm>
+          <a:prstGeom prst="rect">
+            <a:avLst/>
+          </a:prstGeom>
+          <a:solidFill>
+            <a:srgbClr val="FFFFFF"/>
+          </a:solidFill>
+          <a:ln w="19050">
+            <a:solidFill>
+              <a:srgbClr val="ED7D31"/>
+            </a:solidFill>
+          </a:ln>
+          <a:effectLst/>
+        </p:spPr>
+        <p:style>
+          <a:lnRef idx="1">
+            <a:schemeClr val="accent1"/>
+          </a:lnRef>
+          <a:fillRef idx="3">
+            <a:schemeClr val="accent1"/>
+          </a:fillRef>
+          <a:effectRef idx="2">
+            <a:schemeClr val="accent1"/>
+          </a:effectRef>
+          <a:fontRef idx="minor">
+            <a:schemeClr val="lt1"/>
+          </a:fontRef>
+        </p:style>
+        <p:txBody>
+          <a:bodyPr rtlCol="0" anchor="ctr"/>
+          <a:lstStyle/>
+          <a:p>
+            <a:pPr algn="ctr"/>
+          </a:p>
+        </p:txBody>
+      </p:sp>
+      <p:sp>
+        <p:nvSpPr>
+          <p:cNvPr id="15" name="TextBox 14"/>
+          <p:cNvSpPr txBox="1"/>
+          <p:nvPr/>
+        </p:nvSpPr>
+        <p:spPr>
+          <a:xfrm>
+            <a:off x="8476488" y="2203704"/>
+            <a:ext cx="3072384" cy="1472184"/>
+          </a:xfrm>
+          <a:prstGeom prst="rect">
+            <a:avLst/>
+          </a:prstGeom>
+          <a:noFill/>
+        </p:spPr>
+        <p:txBody>
+          <a:bodyPr wrap="square">
+            <a:spAutoFit/>
+          </a:bodyPr>
+          <a:lstStyle/>
+          <a:p>
+            <a:pPr>
+              <a:spcAft>
+                <a:spcPts val="400"/>
+              </a:spcAft>
+            </a:pPr>
+            <a:r>
+              <a:rPr sz="1150">
+                <a:solidFill>
+                  <a:srgbClr val="595959"/>
+                </a:solidFill>
+              </a:rPr>
+              <a:t>•  fato_pedido — 99.441</a:t>
+            </a:r>
+          </a:p>
+          <a:p>
+            <a:pPr>
+              <a:spcAft>
+                <a:spcPts val="400"/>
+              </a:spcAft>
+            </a:pPr>
+            <a:r>
+              <a:rPr sz="1150">
+                <a:solidFill>
+                  <a:srgbClr val="595959"/>
+                </a:solidFill>
+              </a:rPr>
+              <a:t>•  fato_item_pedido — 112.650 ★</a:t>
+            </a:r>
+          </a:p>
+          <a:p>
+            <a:pPr>
+              <a:spcAft>
+                <a:spcPts val="400"/>
+              </a:spcAft>
+            </a:pPr>
+            <a:r>
+              <a:rPr sz="1150">
+                <a:solidFill>
+                  <a:srgbClr val="595959"/>
+                </a:solidFill>
+              </a:rPr>
+              <a:t>•  fato_pagamento — 103.886</a:t>
+            </a:r>
+          </a:p>
+          <a:p>
+            <a:pPr>
+              <a:spcAft>
+                <a:spcPts val="400"/>
+              </a:spcAft>
+            </a:pPr>
+            <a:r>
+              <a:rPr sz="1150">
+                <a:solidFill>
+                  <a:srgbClr val="595959"/>
+                </a:solidFill>
+              </a:rPr>
+              <a:t>•  fato_avaliacao — 99.224</a:t>
+            </a:r>
+          </a:p>
+        </p:txBody>
+      </p:sp>
+      <p:sp>
+        <p:nvSpPr>
+          <p:cNvPr id="16" name="TextBox 15"/>
+          <p:cNvSpPr txBox="1"/>
+          <p:nvPr/>
+        </p:nvSpPr>
+        <p:spPr>
+          <a:xfrm>
+            <a:off x="8366760" y="3703320"/>
+            <a:ext cx="3291840" cy="2377440"/>
           </a:xfrm>
           <a:prstGeom prst="rect">
             <a:avLst/>
@@ -8244,150 +9384,20 @@
           </a:bodyPr>
           <a:lstStyle/>
           <a:p>
-            <a:pPr algn="ctr"/>
-            <a:r>
-              <a:rPr sz="1300" b="1">
-                <a:solidFill>
-                  <a:srgbClr val="1F3864"/>
-                </a:solidFill>
-                <a:latin typeface="Calibri"/>
-              </a:rPr>
-              <a:t>Relacionamentos (simplificado)</a:t>
-            </a:r>
-          </a:p>
-        </p:txBody>
-      </p:sp>
-      <p:sp>
-        <p:nvSpPr>
-          <p:cNvPr id="10" name="TextBox 9"/>
-          <p:cNvSpPr txBox="1"/>
-          <p:nvPr/>
-        </p:nvSpPr>
-        <p:spPr>
-          <a:xfrm>
-            <a:off x="7360920" y="2468880"/>
-            <a:ext cx="4023360" cy="3108960"/>
-          </a:xfrm>
-          <a:prstGeom prst="rect">
-            <a:avLst/>
-          </a:prstGeom>
-          <a:noFill/>
-        </p:spPr>
-        <p:txBody>
-          <a:bodyPr wrap="square">
-            <a:spAutoFit/>
-          </a:bodyPr>
-          <a:lstStyle/>
-          <a:p>
-            <a:pPr>
-              <a:spcAft>
-                <a:spcPts val="1000"/>
-              </a:spcAft>
-            </a:pPr>
-            <a:r>
-              <a:rPr sz="1400" b="0">
+            <a:pPr algn="l"/>
+            <a:r>
+              <a:rPr sz="1200" b="0">
                 <a:solidFill>
                   <a:srgbClr val="595959"/>
                 </a:solidFill>
                 <a:latin typeface="Calibri"/>
               </a:rPr>
-              <a:t>•  customers → orders  (1:N)</a:t>
-            </a:r>
-          </a:p>
-          <a:p>
-            <a:pPr>
-              <a:spcAft>
-                <a:spcPts val="1000"/>
-              </a:spcAft>
-            </a:pPr>
-            <a:r>
-              <a:rPr sz="1400" b="0">
-                <a:solidFill>
-                  <a:srgbClr val="595959"/>
-                </a:solidFill>
-                <a:latin typeface="Calibri"/>
-              </a:rPr>
-              <a:t>•  orders → order_items (1:N)</a:t>
-            </a:r>
-          </a:p>
-          <a:p>
-            <a:pPr>
-              <a:spcAft>
-                <a:spcPts val="1000"/>
-              </a:spcAft>
-            </a:pPr>
-            <a:r>
-              <a:rPr sz="1400" b="0">
-                <a:solidFill>
-                  <a:srgbClr val="595959"/>
-                </a:solidFill>
-                <a:latin typeface="Calibri"/>
-              </a:rPr>
-              <a:t>•  order_items → products (N:1)</a:t>
-            </a:r>
-          </a:p>
-          <a:p>
-            <a:pPr>
-              <a:spcAft>
-                <a:spcPts val="1000"/>
-              </a:spcAft>
-            </a:pPr>
-            <a:r>
-              <a:rPr sz="1400" b="0">
-                <a:solidFill>
-                  <a:srgbClr val="595959"/>
-                </a:solidFill>
-                <a:latin typeface="Calibri"/>
-              </a:rPr>
-              <a:t>•  order_items → sellers (N:1)</a:t>
-            </a:r>
-          </a:p>
-          <a:p>
-            <a:pPr>
-              <a:spcAft>
-                <a:spcPts val="1000"/>
-              </a:spcAft>
-            </a:pPr>
-            <a:r>
-              <a:rPr sz="1400" b="0">
-                <a:solidFill>
-                  <a:srgbClr val="595959"/>
-                </a:solidFill>
-                <a:latin typeface="Calibri"/>
-              </a:rPr>
-              <a:t>•  orders → payments (1:N)</a:t>
-            </a:r>
-          </a:p>
-          <a:p>
-            <a:pPr>
-              <a:spcAft>
-                <a:spcPts val="1000"/>
-              </a:spcAft>
-            </a:pPr>
-            <a:r>
-              <a:rPr sz="1400" b="0">
-                <a:solidFill>
-                  <a:srgbClr val="595959"/>
-                </a:solidFill>
-                <a:latin typeface="Calibri"/>
-              </a:rPr>
-              <a:t>•  orders → reviews (1:1)</a:t>
-            </a:r>
-          </a:p>
-          <a:p>
-            <a:pPr>
-              <a:spcAft>
-                <a:spcPts val="1000"/>
-              </a:spcAft>
-            </a:pPr>
-            <a:r>
-              <a:rPr sz="1400" b="0">
-                <a:solidFill>
-                  <a:srgbClr val="595959"/>
-                </a:solidFill>
-                <a:latin typeface="Calibri"/>
-              </a:rPr>
-              <a:t>•  products → category_translation (N:1)</a:t>
+              <a:t>Decisões de modelagem:
+• Surrogate keys (IDENTITY) nas dimensões.
+• Integridade por PK/FK/UNIQUE/CHECK.
+• Tipagem segura via TRY_CONVERT.
+• ETL transacional e idempotente.
+• ★ maior fato: itens de pedido.</a:t>
             </a:r>
           </a:p>
         </p:txBody>
@@ -8528,7 +9538,7 @@
                 </a:solidFill>
                 <a:latin typeface="Calibri"/>
               </a:rPr>
-              <a:t>Etapa 3 — Engenharia de Dados e ETL</a:t>
+              <a:t>Etapa 2 — Modelagem e Arquitetura</a:t>
             </a:r>
           </a:p>
         </p:txBody>
@@ -8563,7 +9573,7 @@
                 </a:solidFill>
                 <a:latin typeface="Calibri"/>
               </a:rPr>
-              <a:t>Pipeline de ETL e Tratamento de Dados</a:t>
+              <a:t>As 20 Tabelas a Serviço das 10 Perguntas</a:t>
             </a:r>
           </a:p>
         </p:txBody>
@@ -8612,426 +9622,486 @@
           </a:p>
         </p:txBody>
       </p:sp>
-      <p:sp>
-        <p:nvSpPr>
-          <p:cNvPr id="7" name="Rectangle 6"/>
-          <p:cNvSpPr/>
-          <p:nvPr/>
-        </p:nvSpPr>
-        <p:spPr>
-          <a:xfrm>
-            <a:off x="640080" y="1828800"/>
-            <a:ext cx="2468880" cy="1097280"/>
-          </a:xfrm>
-          <a:prstGeom prst="rect">
-            <a:avLst/>
-          </a:prstGeom>
-          <a:solidFill>
-            <a:srgbClr val="2E5496"/>
-          </a:solidFill>
-          <a:ln>
-            <a:noFill/>
-          </a:ln>
-          <a:effectLst/>
-        </p:spPr>
-        <p:style>
-          <a:lnRef idx="1">
-            <a:schemeClr val="accent1"/>
-          </a:lnRef>
-          <a:fillRef idx="3">
-            <a:schemeClr val="accent1"/>
-          </a:fillRef>
-          <a:effectRef idx="2">
-            <a:schemeClr val="accent1"/>
-          </a:effectRef>
-          <a:fontRef idx="minor">
-            <a:schemeClr val="lt1"/>
-          </a:fontRef>
-        </p:style>
-        <p:txBody>
-          <a:bodyPr rtlCol="0" anchor="ctr" wrap="square"/>
-          <a:lstStyle/>
-          <a:p>
-            <a:pPr algn="ctr"/>
-            <a:r>
-              <a:rPr sz="1300" b="1">
-                <a:solidFill>
-                  <a:srgbClr val="FFFFFF"/>
-                </a:solidFill>
-              </a:rPr>
-              <a:t>CSV brutos
-(Kaggle/Olist)</a:t>
-            </a:r>
-          </a:p>
-        </p:txBody>
-      </p:sp>
-      <p:sp>
-        <p:nvSpPr>
-          <p:cNvPr id="8" name="TextBox 7"/>
-          <p:cNvSpPr txBox="1"/>
-          <p:nvPr/>
-        </p:nvSpPr>
-        <p:spPr>
-          <a:xfrm>
-            <a:off x="3108960" y="2148840"/>
-            <a:ext cx="411480" cy="548640"/>
-          </a:xfrm>
-          <a:prstGeom prst="rect">
-            <a:avLst/>
-          </a:prstGeom>
-          <a:noFill/>
-        </p:spPr>
-        <p:txBody>
-          <a:bodyPr wrap="square" anchor="t">
-            <a:spAutoFit/>
-          </a:bodyPr>
-          <a:lstStyle/>
-          <a:p>
-            <a:pPr algn="ctr"/>
-            <a:r>
-              <a:rPr sz="2400" b="1">
-                <a:solidFill>
-                  <a:srgbClr val="ED7D31"/>
-                </a:solidFill>
-                <a:latin typeface="Calibri"/>
-              </a:rPr>
-              <a:t>➜</a:t>
-            </a:r>
-          </a:p>
-        </p:txBody>
-      </p:sp>
-      <p:sp>
-        <p:nvSpPr>
-          <p:cNvPr id="9" name="Rectangle 8"/>
-          <p:cNvSpPr/>
-          <p:nvPr/>
-        </p:nvSpPr>
-        <p:spPr>
-          <a:xfrm>
-            <a:off x="3520440" y="1828800"/>
-            <a:ext cx="2468880" cy="1097280"/>
-          </a:xfrm>
-          <a:prstGeom prst="rect">
-            <a:avLst/>
-          </a:prstGeom>
-          <a:solidFill>
-            <a:srgbClr val="1F3864"/>
-          </a:solidFill>
-          <a:ln>
-            <a:noFill/>
-          </a:ln>
-          <a:effectLst/>
-        </p:spPr>
-        <p:style>
-          <a:lnRef idx="1">
-            <a:schemeClr val="accent1"/>
-          </a:lnRef>
-          <a:fillRef idx="3">
-            <a:schemeClr val="accent1"/>
-          </a:fillRef>
-          <a:effectRef idx="2">
-            <a:schemeClr val="accent1"/>
-          </a:effectRef>
-          <a:fontRef idx="minor">
-            <a:schemeClr val="lt1"/>
-          </a:fontRef>
-        </p:style>
-        <p:txBody>
-          <a:bodyPr rtlCol="0" anchor="ctr" wrap="square"/>
-          <a:lstStyle/>
-          <a:p>
-            <a:pPr algn="ctr"/>
-            <a:r>
-              <a:rPr sz="1300" b="1">
-                <a:solidFill>
-                  <a:srgbClr val="FFFFFF"/>
-                </a:solidFill>
-              </a:rPr>
-              <a:t>BULK INSERT
-(staging raw_*)</a:t>
-            </a:r>
-          </a:p>
-        </p:txBody>
-      </p:sp>
-      <p:sp>
-        <p:nvSpPr>
-          <p:cNvPr id="10" name="TextBox 9"/>
-          <p:cNvSpPr txBox="1"/>
-          <p:nvPr/>
-        </p:nvSpPr>
-        <p:spPr>
-          <a:xfrm>
-            <a:off x="5989320" y="2148840"/>
-            <a:ext cx="411480" cy="548640"/>
-          </a:xfrm>
-          <a:prstGeom prst="rect">
-            <a:avLst/>
-          </a:prstGeom>
-          <a:noFill/>
-        </p:spPr>
-        <p:txBody>
-          <a:bodyPr wrap="square" anchor="t">
-            <a:spAutoFit/>
-          </a:bodyPr>
-          <a:lstStyle/>
-          <a:p>
-            <a:pPr algn="ctr"/>
-            <a:r>
-              <a:rPr sz="2400" b="1">
-                <a:solidFill>
-                  <a:srgbClr val="ED7D31"/>
-                </a:solidFill>
-                <a:latin typeface="Calibri"/>
-              </a:rPr>
-              <a:t>➜</a:t>
-            </a:r>
-          </a:p>
-        </p:txBody>
-      </p:sp>
-      <p:sp>
-        <p:nvSpPr>
-          <p:cNvPr id="11" name="Rectangle 10"/>
-          <p:cNvSpPr/>
-          <p:nvPr/>
-        </p:nvSpPr>
-        <p:spPr>
-          <a:xfrm>
-            <a:off x="6400800" y="1828800"/>
-            <a:ext cx="2468880" cy="1097280"/>
-          </a:xfrm>
-          <a:prstGeom prst="rect">
-            <a:avLst/>
-          </a:prstGeom>
-          <a:solidFill>
-            <a:srgbClr val="2E5496"/>
-          </a:solidFill>
-          <a:ln>
-            <a:noFill/>
-          </a:ln>
-          <a:effectLst/>
-        </p:spPr>
-        <p:style>
-          <a:lnRef idx="1">
-            <a:schemeClr val="accent1"/>
-          </a:lnRef>
-          <a:fillRef idx="3">
-            <a:schemeClr val="accent1"/>
-          </a:fillRef>
-          <a:effectRef idx="2">
-            <a:schemeClr val="accent1"/>
-          </a:effectRef>
-          <a:fontRef idx="minor">
-            <a:schemeClr val="lt1"/>
-          </a:fontRef>
-        </p:style>
-        <p:txBody>
-          <a:bodyPr rtlCol="0" anchor="ctr" wrap="square"/>
-          <a:lstStyle/>
-          <a:p>
-            <a:pPr algn="ctr"/>
-            <a:r>
-              <a:rPr sz="1300" b="1">
-                <a:solidFill>
-                  <a:srgbClr val="FFFFFF"/>
-                </a:solidFill>
-              </a:rPr>
-              <a:t>Limpeza &amp;
-Tipagem</a:t>
-            </a:r>
-          </a:p>
-        </p:txBody>
-      </p:sp>
-      <p:sp>
-        <p:nvSpPr>
-          <p:cNvPr id="12" name="TextBox 11"/>
-          <p:cNvSpPr txBox="1"/>
-          <p:nvPr/>
-        </p:nvSpPr>
-        <p:spPr>
-          <a:xfrm>
-            <a:off x="8869680" y="2148840"/>
-            <a:ext cx="411480" cy="548640"/>
-          </a:xfrm>
-          <a:prstGeom prst="rect">
-            <a:avLst/>
-          </a:prstGeom>
-          <a:noFill/>
-        </p:spPr>
-        <p:txBody>
-          <a:bodyPr wrap="square" anchor="t">
-            <a:spAutoFit/>
-          </a:bodyPr>
-          <a:lstStyle/>
-          <a:p>
-            <a:pPr algn="ctr"/>
-            <a:r>
-              <a:rPr sz="2400" b="1">
-                <a:solidFill>
-                  <a:srgbClr val="ED7D31"/>
-                </a:solidFill>
-                <a:latin typeface="Calibri"/>
-              </a:rPr>
-              <a:t>➜</a:t>
-            </a:r>
-          </a:p>
-        </p:txBody>
-      </p:sp>
-      <p:sp>
-        <p:nvSpPr>
-          <p:cNvPr id="13" name="Rectangle 12"/>
-          <p:cNvSpPr/>
-          <p:nvPr/>
-        </p:nvSpPr>
-        <p:spPr>
-          <a:xfrm>
-            <a:off x="9281160" y="1828800"/>
-            <a:ext cx="2468880" cy="1097280"/>
-          </a:xfrm>
-          <a:prstGeom prst="rect">
-            <a:avLst/>
-          </a:prstGeom>
-          <a:solidFill>
-            <a:srgbClr val="1F3864"/>
-          </a:solidFill>
-          <a:ln>
-            <a:noFill/>
-          </a:ln>
-          <a:effectLst/>
-        </p:spPr>
-        <p:style>
-          <a:lnRef idx="1">
-            <a:schemeClr val="accent1"/>
-          </a:lnRef>
-          <a:fillRef idx="3">
-            <a:schemeClr val="accent1"/>
-          </a:fillRef>
-          <a:effectRef idx="2">
-            <a:schemeClr val="accent1"/>
-          </a:effectRef>
-          <a:fontRef idx="minor">
-            <a:schemeClr val="lt1"/>
-          </a:fontRef>
-        </p:style>
-        <p:txBody>
-          <a:bodyPr rtlCol="0" anchor="ctr" wrap="square"/>
-          <a:lstStyle/>
-          <a:p>
-            <a:pPr algn="ctr"/>
-            <a:r>
-              <a:rPr sz="1300" b="1">
-                <a:solidFill>
-                  <a:srgbClr val="FFFFFF"/>
-                </a:solidFill>
-              </a:rPr>
-              <a:t>Consultas
-Analíticas (DQL)</a:t>
-            </a:r>
-          </a:p>
-        </p:txBody>
-      </p:sp>
-      <p:sp>
-        <p:nvSpPr>
-          <p:cNvPr id="14" name="TextBox 13"/>
-          <p:cNvSpPr txBox="1"/>
-          <p:nvPr/>
-        </p:nvSpPr>
-        <p:spPr>
-          <a:xfrm>
-            <a:off x="640080" y="3383280"/>
-            <a:ext cx="10972800" cy="2743200"/>
-          </a:xfrm>
-          <a:prstGeom prst="rect">
-            <a:avLst/>
-          </a:prstGeom>
-          <a:noFill/>
-        </p:spPr>
-        <p:txBody>
-          <a:bodyPr wrap="square">
-            <a:spAutoFit/>
-          </a:bodyPr>
-          <a:lstStyle/>
-          <a:p>
-            <a:pPr>
-              <a:spcAft>
-                <a:spcPts val="900"/>
-              </a:spcAft>
-            </a:pPr>
-            <a:r>
-              <a:rPr sz="1500" b="0">
-                <a:solidFill>
-                  <a:srgbClr val="595959"/>
-                </a:solidFill>
-                <a:latin typeface="Calibri"/>
-              </a:rPr>
-              <a:t>•  **Extração robusta:** BULK INSERT com FORMAT='CSV' (trata campos entre aspas).</a:t>
-            </a:r>
-          </a:p>
-          <a:p>
-            <a:pPr>
-              <a:spcAft>
-                <a:spcPts val="900"/>
-              </a:spcAft>
-            </a:pPr>
-            <a:r>
-              <a:rPr sz="1500" b="0">
-                <a:solidFill>
-                  <a:srgbClr val="595959"/>
-                </a:solidFill>
-                <a:latin typeface="Calibri"/>
-              </a:rPr>
-              <a:t>•  **Valores nulos:** datas de entrega ausentes tratadas; conversão tolerante com TRY_CONVERT.</a:t>
-            </a:r>
-          </a:p>
-          <a:p>
-            <a:pPr>
-              <a:spcAft>
-                <a:spcPts val="900"/>
-              </a:spcAft>
-            </a:pPr>
-            <a:r>
-              <a:rPr sz="1500" b="0">
-                <a:solidFill>
-                  <a:srgbClr val="595959"/>
-                </a:solidFill>
-                <a:latin typeface="Calibri"/>
-              </a:rPr>
-              <a:t>•  **Texto sujo:** avaliações com texto livre/quebras de linha → arquivo reviews_limpo pré-tratado.</a:t>
-            </a:r>
-          </a:p>
-          <a:p>
-            <a:pPr>
-              <a:spcAft>
-                <a:spcPts val="900"/>
-              </a:spcAft>
-            </a:pPr>
-            <a:r>
-              <a:rPr sz="1500" b="0">
-                <a:solidFill>
-                  <a:srgbClr val="595959"/>
-                </a:solidFill>
-                <a:latin typeface="Calibri"/>
-              </a:rPr>
-              <a:t>•  **Formatos inconsistentes:** timestamps e decimais convertidos no momento da análise.</a:t>
-            </a:r>
-          </a:p>
-          <a:p>
-            <a:pPr>
-              <a:spcAft>
-                <a:spcPts val="900"/>
-              </a:spcAft>
-            </a:pPr>
-            <a:r>
-              <a:rPr sz="1500" b="0">
-                <a:solidFill>
-                  <a:srgbClr val="595959"/>
-                </a:solidFill>
-                <a:latin typeface="Calibri"/>
-              </a:rPr>
-              <a:t>•  **Reexecução:** scripts idempotentes (DROP IF EXISTS + recarga) garantem carga repetível.</a:t>
-            </a:r>
-          </a:p>
-        </p:txBody>
-      </p:sp>
+      <p:graphicFrame>
+        <p:nvGraphicFramePr>
+          <p:cNvPr id="7" name="Table 6"/>
+          <p:cNvGraphicFramePr>
+            <a:graphicFrameLocks noGrp="1"/>
+          </p:cNvGraphicFramePr>
+          <p:nvPr/>
+        </p:nvGraphicFramePr>
+        <p:xfrm>
+          <a:off x="548640" y="1645920"/>
+          <a:ext cx="11064240" cy="4754880"/>
+        </p:xfrm>
+        <a:graphic>
+          <a:graphicData uri="http://schemas.openxmlformats.org/drawingml/2006/table">
+            <a:tbl>
+              <a:tblPr firstRow="1" bandRow="1">
+                <a:tableStyleId>{5C22544A-7EE6-4342-B048-85BDC9FD1C3A}</a:tableStyleId>
+              </a:tblPr>
+              <a:tblGrid>
+                <a:gridCol w="4846320"/>
+                <a:gridCol w="6217920"/>
+              </a:tblGrid>
+              <a:tr h="432261">
+                <a:tc>
+                  <a:txBody>
+                    <a:bodyPr/>
+                    <a:lstStyle/>
+                    <a:p>
+                      <a:r>
+                        <a:rPr b="1" sz="1300">
+                          <a:solidFill>
+                            <a:srgbClr val="FFFFFF"/>
+                          </a:solidFill>
+                        </a:rPr>
+                        <a:t>Pergunta de negócio</a:t>
+                      </a:r>
+                    </a:p>
+                  </a:txBody>
+                  <a:tcPr>
+                    <a:solidFill>
+                      <a:srgbClr val="1F3864"/>
+                    </a:solidFill>
+                  </a:tcPr>
+                </a:tc>
+                <a:tc>
+                  <a:txBody>
+                    <a:bodyPr/>
+                    <a:lstStyle/>
+                    <a:p>
+                      <a:r>
+                        <a:rPr b="1" sz="1300">
+                          <a:solidFill>
+                            <a:srgbClr val="FFFFFF"/>
+                          </a:solidFill>
+                        </a:rPr>
+                        <a:t>Tabelas do modelo utilizadas</a:t>
+                      </a:r>
+                    </a:p>
+                  </a:txBody>
+                  <a:tcPr>
+                    <a:solidFill>
+                      <a:srgbClr val="1F3864"/>
+                    </a:solidFill>
+                  </a:tcPr>
+                </a:tc>
+              </a:tr>
+              <a:tr h="432261">
+                <a:tc>
+                  <a:txBody>
+                    <a:bodyPr/>
+                    <a:lstStyle/>
+                    <a:p>
+                      <a:r>
+                        <a:rPr sz="1200">
+                          <a:solidFill>
+                            <a:srgbClr val="595959"/>
+                          </a:solidFill>
+                        </a:rPr>
+                        <a:t>1. Forma de pagamento mais usada</a:t>
+                      </a:r>
+                    </a:p>
+                  </a:txBody>
+                  <a:tcPr/>
+                </a:tc>
+                <a:tc>
+                  <a:txBody>
+                    <a:bodyPr/>
+                    <a:lstStyle/>
+                    <a:p>
+                      <a:r>
+                        <a:rPr sz="1200">
+                          <a:solidFill>
+                            <a:srgbClr val="595959"/>
+                          </a:solidFill>
+                          <a:latin typeface="Consolas"/>
+                        </a:rPr>
+                        <a:t>fato_pagamento + dim_forma_pagamento</a:t>
+                      </a:r>
+                    </a:p>
+                  </a:txBody>
+                  <a:tcPr/>
+                </a:tc>
+              </a:tr>
+              <a:tr h="432261">
+                <a:tc>
+                  <a:txBody>
+                    <a:bodyPr/>
+                    <a:lstStyle/>
+                    <a:p>
+                      <a:r>
+                        <a:rPr sz="1200">
+                          <a:solidFill>
+                            <a:srgbClr val="595959"/>
+                          </a:solidFill>
+                        </a:rPr>
+                        <a:t>2. Taxa de recompra</a:t>
+                      </a:r>
+                    </a:p>
+                  </a:txBody>
+                  <a:tcPr>
+                    <a:solidFill>
+                      <a:srgbClr val="EEF3FB"/>
+                    </a:solidFill>
+                  </a:tcPr>
+                </a:tc>
+                <a:tc>
+                  <a:txBody>
+                    <a:bodyPr/>
+                    <a:lstStyle/>
+                    <a:p>
+                      <a:r>
+                        <a:rPr sz="1200">
+                          <a:solidFill>
+                            <a:srgbClr val="595959"/>
+                          </a:solidFill>
+                          <a:latin typeface="Consolas"/>
+                        </a:rPr>
+                        <a:t>fato_pedido + dim_cliente</a:t>
+                      </a:r>
+                    </a:p>
+                  </a:txBody>
+                  <a:tcPr>
+                    <a:solidFill>
+                      <a:srgbClr val="EEF3FB"/>
+                    </a:solidFill>
+                  </a:tcPr>
+                </a:tc>
+              </a:tr>
+              <a:tr h="432261">
+                <a:tc>
+                  <a:txBody>
+                    <a:bodyPr/>
+                    <a:lstStyle/>
+                    <a:p>
+                      <a:r>
+                        <a:rPr sz="1200">
+                          <a:solidFill>
+                            <a:srgbClr val="595959"/>
+                          </a:solidFill>
+                        </a:rPr>
+                        <a:t>3. Estados com mais clientes</a:t>
+                      </a:r>
+                    </a:p>
+                  </a:txBody>
+                  <a:tcPr/>
+                </a:tc>
+                <a:tc>
+                  <a:txBody>
+                    <a:bodyPr/>
+                    <a:lstStyle/>
+                    <a:p>
+                      <a:r>
+                        <a:rPr sz="1200">
+                          <a:solidFill>
+                            <a:srgbClr val="595959"/>
+                          </a:solidFill>
+                          <a:latin typeface="Consolas"/>
+                        </a:rPr>
+                        <a:t>dim_cliente + fato_pedido</a:t>
+                      </a:r>
+                    </a:p>
+                  </a:txBody>
+                  <a:tcPr/>
+                </a:tc>
+              </a:tr>
+              <a:tr h="432261">
+                <a:tc>
+                  <a:txBody>
+                    <a:bodyPr/>
+                    <a:lstStyle/>
+                    <a:p>
+                      <a:r>
+                        <a:rPr sz="1200">
+                          <a:solidFill>
+                            <a:srgbClr val="595959"/>
+                          </a:solidFill>
+                        </a:rPr>
+                        <a:t>4. Meses de maior venda</a:t>
+                      </a:r>
+                    </a:p>
+                  </a:txBody>
+                  <a:tcPr>
+                    <a:solidFill>
+                      <a:srgbClr val="EEF3FB"/>
+                    </a:solidFill>
+                  </a:tcPr>
+                </a:tc>
+                <a:tc>
+                  <a:txBody>
+                    <a:bodyPr/>
+                    <a:lstStyle/>
+                    <a:p>
+                      <a:r>
+                        <a:rPr sz="1200">
+                          <a:solidFill>
+                            <a:srgbClr val="595959"/>
+                          </a:solidFill>
+                          <a:latin typeface="Consolas"/>
+                        </a:rPr>
+                        <a:t>fato_item_pedido + dim_tempo</a:t>
+                      </a:r>
+                    </a:p>
+                  </a:txBody>
+                  <a:tcPr>
+                    <a:solidFill>
+                      <a:srgbClr val="EEF3FB"/>
+                    </a:solidFill>
+                  </a:tcPr>
+                </a:tc>
+              </a:tr>
+              <a:tr h="432261">
+                <a:tc>
+                  <a:txBody>
+                    <a:bodyPr/>
+                    <a:lstStyle/>
+                    <a:p>
+                      <a:r>
+                        <a:rPr sz="1200">
+                          <a:solidFill>
+                            <a:srgbClr val="595959"/>
+                          </a:solidFill>
+                        </a:rPr>
+                        <a:t>5. Categorias mais vendidas</a:t>
+                      </a:r>
+                    </a:p>
+                  </a:txBody>
+                  <a:tcPr/>
+                </a:tc>
+                <a:tc>
+                  <a:txBody>
+                    <a:bodyPr/>
+                    <a:lstStyle/>
+                    <a:p>
+                      <a:r>
+                        <a:rPr sz="1200">
+                          <a:solidFill>
+                            <a:srgbClr val="595959"/>
+                          </a:solidFill>
+                          <a:latin typeface="Consolas"/>
+                        </a:rPr>
+                        <a:t>fato_item_pedido + dim_produto + dim_categoria</a:t>
+                      </a:r>
+                    </a:p>
+                  </a:txBody>
+                  <a:tcPr/>
+                </a:tc>
+              </a:tr>
+              <a:tr h="432261">
+                <a:tc>
+                  <a:txBody>
+                    <a:bodyPr/>
+                    <a:lstStyle/>
+                    <a:p>
+                      <a:r>
+                        <a:rPr sz="1200">
+                          <a:solidFill>
+                            <a:srgbClr val="595959"/>
+                          </a:solidFill>
+                        </a:rPr>
+                        <a:t>6. Crescimento MoM</a:t>
+                      </a:r>
+                    </a:p>
+                  </a:txBody>
+                  <a:tcPr>
+                    <a:solidFill>
+                      <a:srgbClr val="EEF3FB"/>
+                    </a:solidFill>
+                  </a:tcPr>
+                </a:tc>
+                <a:tc>
+                  <a:txBody>
+                    <a:bodyPr/>
+                    <a:lstStyle/>
+                    <a:p>
+                      <a:r>
+                        <a:rPr sz="1200">
+                          <a:solidFill>
+                            <a:srgbClr val="595959"/>
+                          </a:solidFill>
+                          <a:latin typeface="Consolas"/>
+                        </a:rPr>
+                        <a:t>fato_item_pedido + dim_tempo</a:t>
+                      </a:r>
+                    </a:p>
+                  </a:txBody>
+                  <a:tcPr>
+                    <a:solidFill>
+                      <a:srgbClr val="EEF3FB"/>
+                    </a:solidFill>
+                  </a:tcPr>
+                </a:tc>
+              </a:tr>
+              <a:tr h="432261">
+                <a:tc>
+                  <a:txBody>
+                    <a:bodyPr/>
+                    <a:lstStyle/>
+                    <a:p>
+                      <a:r>
+                        <a:rPr sz="1200">
+                          <a:solidFill>
+                            <a:srgbClr val="595959"/>
+                          </a:solidFill>
+                        </a:rPr>
+                        <a:t>7. Tempo médio de entrega</a:t>
+                      </a:r>
+                    </a:p>
+                  </a:txBody>
+                  <a:tcPr/>
+                </a:tc>
+                <a:tc>
+                  <a:txBody>
+                    <a:bodyPr/>
+                    <a:lstStyle/>
+                    <a:p>
+                      <a:r>
+                        <a:rPr sz="1200">
+                          <a:solidFill>
+                            <a:srgbClr val="595959"/>
+                          </a:solidFill>
+                          <a:latin typeface="Consolas"/>
+                        </a:rPr>
+                        <a:t>fato_pedido + dim_tempo</a:t>
+                      </a:r>
+                    </a:p>
+                  </a:txBody>
+                  <a:tcPr/>
+                </a:tc>
+              </a:tr>
+              <a:tr h="432261">
+                <a:tc>
+                  <a:txBody>
+                    <a:bodyPr/>
+                    <a:lstStyle/>
+                    <a:p>
+                      <a:r>
+                        <a:rPr sz="1200">
+                          <a:solidFill>
+                            <a:srgbClr val="595959"/>
+                          </a:solidFill>
+                        </a:rPr>
+                        <a:t>8. Motivos de cancelamento</a:t>
+                      </a:r>
+                    </a:p>
+                  </a:txBody>
+                  <a:tcPr>
+                    <a:solidFill>
+                      <a:srgbClr val="EEF3FB"/>
+                    </a:solidFill>
+                  </a:tcPr>
+                </a:tc>
+                <a:tc>
+                  <a:txBody>
+                    <a:bodyPr/>
+                    <a:lstStyle/>
+                    <a:p>
+                      <a:r>
+                        <a:rPr sz="1200">
+                          <a:solidFill>
+                            <a:srgbClr val="595959"/>
+                          </a:solidFill>
+                          <a:latin typeface="Consolas"/>
+                        </a:rPr>
+                        <a:t>fato_pedido + dim_status_pedido</a:t>
+                      </a:r>
+                    </a:p>
+                  </a:txBody>
+                  <a:tcPr>
+                    <a:solidFill>
+                      <a:srgbClr val="EEF3FB"/>
+                    </a:solidFill>
+                  </a:tcPr>
+                </a:tc>
+              </a:tr>
+              <a:tr h="432261">
+                <a:tc>
+                  <a:txBody>
+                    <a:bodyPr/>
+                    <a:lstStyle/>
+                    <a:p>
+                      <a:r>
+                        <a:rPr sz="1200">
+                          <a:solidFill>
+                            <a:srgbClr val="595959"/>
+                          </a:solidFill>
+                        </a:rPr>
+                        <a:t>9. Vendedores com mais receita</a:t>
+                      </a:r>
+                    </a:p>
+                  </a:txBody>
+                  <a:tcPr/>
+                </a:tc>
+                <a:tc>
+                  <a:txBody>
+                    <a:bodyPr/>
+                    <a:lstStyle/>
+                    <a:p>
+                      <a:r>
+                        <a:rPr sz="1200">
+                          <a:solidFill>
+                            <a:srgbClr val="595959"/>
+                          </a:solidFill>
+                          <a:latin typeface="Consolas"/>
+                        </a:rPr>
+                        <a:t>fato_item_pedido + dim_vendedor</a:t>
+                      </a:r>
+                    </a:p>
+                  </a:txBody>
+                  <a:tcPr/>
+                </a:tc>
+              </a:tr>
+              <a:tr h="432270">
+                <a:tc>
+                  <a:txBody>
+                    <a:bodyPr/>
+                    <a:lstStyle/>
+                    <a:p>
+                      <a:r>
+                        <a:rPr sz="1200">
+                          <a:solidFill>
+                            <a:srgbClr val="595959"/>
+                          </a:solidFill>
+                        </a:rPr>
+                        <a:t>10. Satisfação dos clientes</a:t>
+                      </a:r>
+                    </a:p>
+                  </a:txBody>
+                  <a:tcPr>
+                    <a:solidFill>
+                      <a:srgbClr val="EEF3FB"/>
+                    </a:solidFill>
+                  </a:tcPr>
+                </a:tc>
+                <a:tc>
+                  <a:txBody>
+                    <a:bodyPr/>
+                    <a:lstStyle/>
+                    <a:p>
+                      <a:r>
+                        <a:rPr sz="1200">
+                          <a:solidFill>
+                            <a:srgbClr val="595959"/>
+                          </a:solidFill>
+                          <a:latin typeface="Consolas"/>
+                        </a:rPr>
+                        <a:t>fato_avaliacao + dim_avaliacao</a:t>
+                      </a:r>
+                    </a:p>
+                  </a:txBody>
+                  <a:tcPr>
+                    <a:solidFill>
+                      <a:srgbClr val="EEF3FB"/>
+                    </a:solidFill>
+                  </a:tcPr>
+                </a:tc>
+              </a:tr>
+            </a:tbl>
+          </a:graphicData>
+        </a:graphic>
+      </p:graphicFrame>
     </p:spTree>
   </p:cSld>
   <p:clrMapOvr>
@@ -9168,7 +10238,7 @@
                 </a:solidFill>
                 <a:latin typeface="Calibri"/>
               </a:rPr>
-              <a:t>Etapa 4 — Análise de Dados e Insights</a:t>
+              <a:t>Etapa 3 — Engenharia de Dados e ETL</a:t>
             </a:r>
           </a:p>
         </p:txBody>
@@ -9203,7 +10273,7 @@
                 </a:solidFill>
                 <a:latin typeface="Calibri"/>
               </a:rPr>
-              <a:t>Pagamentos e Recompra (P1 e P2)</a:t>
+              <a:t>Pipeline de ETL e Tratamento de Dados</a:t>
             </a:r>
           </a:p>
         </p:txBody>
@@ -9260,19 +10330,17 @@
         </p:nvSpPr>
         <p:spPr>
           <a:xfrm>
-            <a:off x="640080" y="1691640"/>
-            <a:ext cx="2651760" cy="1371600"/>
+            <a:off x="640080" y="1828800"/>
+            <a:ext cx="2468880" cy="1097280"/>
           </a:xfrm>
           <a:prstGeom prst="rect">
             <a:avLst/>
           </a:prstGeom>
           <a:solidFill>
-            <a:srgbClr val="FFFFFF"/>
+            <a:srgbClr val="2E5496"/>
           </a:solidFill>
-          <a:ln w="12700">
-            <a:solidFill>
-              <a:srgbClr val="2E5496"/>
-            </a:solidFill>
+          <a:ln>
+            <a:noFill/>
           </a:ln>
           <a:effectLst/>
         </p:spPr>
@@ -9291,10 +10359,19 @@
           </a:fontRef>
         </p:style>
         <p:txBody>
-          <a:bodyPr rtlCol="0" anchor="ctr"/>
+          <a:bodyPr rtlCol="0" anchor="ctr" wrap="square"/>
           <a:lstStyle/>
           <a:p>
             <a:pPr algn="ctr"/>
+            <a:r>
+              <a:rPr sz="1300" b="1">
+                <a:solidFill>
+                  <a:srgbClr val="FFFFFF"/>
+                </a:solidFill>
+              </a:rPr>
+              <a:t>CSV brutos
+(Kaggle/Olist)</a:t>
+            </a:r>
           </a:p>
         </p:txBody>
       </p:sp>
@@ -9306,43 +10383,8 @@
         </p:nvSpPr>
         <p:spPr>
           <a:xfrm>
-            <a:off x="640080" y="1856232"/>
-            <a:ext cx="2651760" cy="640080"/>
-          </a:xfrm>
-          <a:prstGeom prst="rect">
-            <a:avLst/>
-          </a:prstGeom>
-          <a:noFill/>
-        </p:spPr>
-        <p:txBody>
-          <a:bodyPr wrap="square" anchor="ctr">
-            <a:spAutoFit/>
-          </a:bodyPr>
-          <a:lstStyle/>
-          <a:p>
-            <a:pPr algn="ctr"/>
-            <a:r>
-              <a:rPr sz="3000" b="1">
-                <a:solidFill>
-                  <a:srgbClr val="1F3864"/>
-                </a:solidFill>
-                <a:latin typeface="Calibri"/>
-              </a:rPr>
-              <a:t>73,9%</a:t>
-            </a:r>
-          </a:p>
-        </p:txBody>
-      </p:sp>
-      <p:sp>
-        <p:nvSpPr>
-          <p:cNvPr id="9" name="TextBox 8"/>
-          <p:cNvSpPr txBox="1"/>
-          <p:nvPr/>
-        </p:nvSpPr>
-        <p:spPr>
-          <a:xfrm>
-            <a:off x="640080" y="2560320"/>
-            <a:ext cx="2651760" cy="411480"/>
+            <a:off x="3108960" y="2148840"/>
+            <a:ext cx="411480" cy="548640"/>
           </a:xfrm>
           <a:prstGeom prst="rect">
             <a:avLst/>
@@ -9357,38 +10399,36 @@
           <a:p>
             <a:pPr algn="ctr"/>
             <a:r>
-              <a:rPr sz="1200" b="0">
-                <a:solidFill>
-                  <a:srgbClr val="595959"/>
-                </a:solidFill>
-                <a:latin typeface="Calibri"/>
-              </a:rPr>
-              <a:t>no cartão de crédito</a:t>
-            </a:r>
-          </a:p>
-        </p:txBody>
-      </p:sp>
-      <p:sp>
-        <p:nvSpPr>
-          <p:cNvPr id="10" name="Rectangle 9"/>
+              <a:rPr sz="2400" b="1">
+                <a:solidFill>
+                  <a:srgbClr val="ED7D31"/>
+                </a:solidFill>
+                <a:latin typeface="Calibri"/>
+              </a:rPr>
+              <a:t>➜</a:t>
+            </a:r>
+          </a:p>
+        </p:txBody>
+      </p:sp>
+      <p:sp>
+        <p:nvSpPr>
+          <p:cNvPr id="9" name="Rectangle 8"/>
           <p:cNvSpPr/>
           <p:nvPr/>
         </p:nvSpPr>
         <p:spPr>
           <a:xfrm>
-            <a:off x="3429000" y="1691640"/>
-            <a:ext cx="2651760" cy="1371600"/>
+            <a:off x="3520440" y="1828800"/>
+            <a:ext cx="2468880" cy="1097280"/>
           </a:xfrm>
           <a:prstGeom prst="rect">
             <a:avLst/>
           </a:prstGeom>
           <a:solidFill>
-            <a:srgbClr val="FFFFFF"/>
+            <a:srgbClr val="1F3864"/>
           </a:solidFill>
-          <a:ln w="12700">
-            <a:solidFill>
-              <a:srgbClr val="2E5496"/>
-            </a:solidFill>
+          <a:ln>
+            <a:noFill/>
           </a:ln>
           <a:effectLst/>
         </p:spPr>
@@ -9407,58 +10447,32 @@
           </a:fontRef>
         </p:style>
         <p:txBody>
-          <a:bodyPr rtlCol="0" anchor="ctr"/>
+          <a:bodyPr rtlCol="0" anchor="ctr" wrap="square"/>
           <a:lstStyle/>
           <a:p>
             <a:pPr algn="ctr"/>
-          </a:p>
-        </p:txBody>
-      </p:sp>
-      <p:sp>
-        <p:nvSpPr>
-          <p:cNvPr id="11" name="TextBox 10"/>
+            <a:r>
+              <a:rPr sz="1300" b="1">
+                <a:solidFill>
+                  <a:srgbClr val="FFFFFF"/>
+                </a:solidFill>
+              </a:rPr>
+              <a:t>BULK INSERT
+(staging raw_*)</a:t>
+            </a:r>
+          </a:p>
+        </p:txBody>
+      </p:sp>
+      <p:sp>
+        <p:nvSpPr>
+          <p:cNvPr id="10" name="TextBox 9"/>
           <p:cNvSpPr txBox="1"/>
           <p:nvPr/>
         </p:nvSpPr>
         <p:spPr>
           <a:xfrm>
-            <a:off x="3429000" y="1856232"/>
-            <a:ext cx="2651760" cy="640080"/>
-          </a:xfrm>
-          <a:prstGeom prst="rect">
-            <a:avLst/>
-          </a:prstGeom>
-          <a:noFill/>
-        </p:spPr>
-        <p:txBody>
-          <a:bodyPr wrap="square" anchor="ctr">
-            <a:spAutoFit/>
-          </a:bodyPr>
-          <a:lstStyle/>
-          <a:p>
-            <a:pPr algn="ctr"/>
-            <a:r>
-              <a:rPr sz="3000" b="1">
-                <a:solidFill>
-                  <a:srgbClr val="1F3864"/>
-                </a:solidFill>
-                <a:latin typeface="Calibri"/>
-              </a:rPr>
-              <a:t>3,12%</a:t>
-            </a:r>
-          </a:p>
-        </p:txBody>
-      </p:sp>
-      <p:sp>
-        <p:nvSpPr>
-          <p:cNvPr id="12" name="TextBox 11"/>
-          <p:cNvSpPr txBox="1"/>
-          <p:nvPr/>
-        </p:nvSpPr>
-        <p:spPr>
-          <a:xfrm>
-            <a:off x="3429000" y="2560320"/>
-            <a:ext cx="2651760" cy="411480"/>
+            <a:off x="5989320" y="2148840"/>
+            <a:ext cx="411480" cy="548640"/>
           </a:xfrm>
           <a:prstGeom prst="rect">
             <a:avLst/>
@@ -9473,38 +10487,36 @@
           <a:p>
             <a:pPr algn="ctr"/>
             <a:r>
-              <a:rPr sz="1200" b="0">
-                <a:solidFill>
-                  <a:srgbClr val="595959"/>
-                </a:solidFill>
-                <a:latin typeface="Calibri"/>
-              </a:rPr>
-              <a:t>taxa de recompra</a:t>
-            </a:r>
-          </a:p>
-        </p:txBody>
-      </p:sp>
-      <p:sp>
-        <p:nvSpPr>
-          <p:cNvPr id="13" name="Rectangle 12"/>
+              <a:rPr sz="2400" b="1">
+                <a:solidFill>
+                  <a:srgbClr val="ED7D31"/>
+                </a:solidFill>
+                <a:latin typeface="Calibri"/>
+              </a:rPr>
+              <a:t>➜</a:t>
+            </a:r>
+          </a:p>
+        </p:txBody>
+      </p:sp>
+      <p:sp>
+        <p:nvSpPr>
+          <p:cNvPr id="11" name="Rectangle 10"/>
           <p:cNvSpPr/>
           <p:nvPr/>
         </p:nvSpPr>
         <p:spPr>
           <a:xfrm>
-            <a:off x="6217920" y="1691640"/>
-            <a:ext cx="2651760" cy="1371600"/>
+            <a:off x="6400800" y="1828800"/>
+            <a:ext cx="2468880" cy="1097280"/>
           </a:xfrm>
           <a:prstGeom prst="rect">
             <a:avLst/>
           </a:prstGeom>
           <a:solidFill>
-            <a:srgbClr val="FFFFFF"/>
+            <a:srgbClr val="2E5496"/>
           </a:solidFill>
-          <a:ln w="12700">
-            <a:solidFill>
-              <a:srgbClr val="2E5496"/>
-            </a:solidFill>
+          <a:ln>
+            <a:noFill/>
           </a:ln>
           <a:effectLst/>
         </p:spPr>
@@ -9523,58 +10535,32 @@
           </a:fontRef>
         </p:style>
         <p:txBody>
-          <a:bodyPr rtlCol="0" anchor="ctr"/>
+          <a:bodyPr rtlCol="0" anchor="ctr" wrap="square"/>
           <a:lstStyle/>
           <a:p>
             <a:pPr algn="ctr"/>
-          </a:p>
-        </p:txBody>
-      </p:sp>
-      <p:sp>
-        <p:nvSpPr>
-          <p:cNvPr id="14" name="TextBox 13"/>
+            <a:r>
+              <a:rPr sz="1300" b="1">
+                <a:solidFill>
+                  <a:srgbClr val="FFFFFF"/>
+                </a:solidFill>
+              </a:rPr>
+              <a:t>Limpeza &amp;
+Tipagem</a:t>
+            </a:r>
+          </a:p>
+        </p:txBody>
+      </p:sp>
+      <p:sp>
+        <p:nvSpPr>
+          <p:cNvPr id="12" name="TextBox 11"/>
           <p:cNvSpPr txBox="1"/>
           <p:nvPr/>
         </p:nvSpPr>
         <p:spPr>
           <a:xfrm>
-            <a:off x="6217920" y="1856232"/>
-            <a:ext cx="2651760" cy="640080"/>
-          </a:xfrm>
-          <a:prstGeom prst="rect">
-            <a:avLst/>
-          </a:prstGeom>
-          <a:noFill/>
-        </p:spPr>
-        <p:txBody>
-          <a:bodyPr wrap="square" anchor="ctr">
-            <a:spAutoFit/>
-          </a:bodyPr>
-          <a:lstStyle/>
-          <a:p>
-            <a:pPr algn="ctr"/>
-            <a:r>
-              <a:rPr sz="2200" b="1">
-                <a:solidFill>
-                  <a:srgbClr val="1F3864"/>
-                </a:solidFill>
-                <a:latin typeface="Calibri"/>
-              </a:rPr>
-              <a:t>R$ 12,5 mi</a:t>
-            </a:r>
-          </a:p>
-        </p:txBody>
-      </p:sp>
-      <p:sp>
-        <p:nvSpPr>
-          <p:cNvPr id="15" name="TextBox 14"/>
-          <p:cNvSpPr txBox="1"/>
-          <p:nvPr/>
-        </p:nvSpPr>
-        <p:spPr>
-          <a:xfrm>
-            <a:off x="6217920" y="2560320"/>
-            <a:ext cx="2651760" cy="411480"/>
+            <a:off x="8869680" y="2148840"/>
+            <a:ext cx="411480" cy="548640"/>
           </a:xfrm>
           <a:prstGeom prst="rect">
             <a:avLst/>
@@ -9589,45 +10575,80 @@
           <a:p>
             <a:pPr algn="ctr"/>
             <a:r>
-              <a:rPr sz="1200" b="0">
-                <a:solidFill>
-                  <a:srgbClr val="595959"/>
-                </a:solidFill>
-                <a:latin typeface="Calibri"/>
-              </a:rPr>
-              <a:t>via crédito</a:t>
-            </a:r>
-          </a:p>
-        </p:txBody>
-      </p:sp>
-      <p:graphicFrame>
-        <p:nvGraphicFramePr>
-          <p:cNvPr id="16" name="Chart 15"/>
-          <p:cNvGraphicFramePr>
-            <a:graphicFrameLocks noGrp="1"/>
-          </p:cNvGraphicFramePr>
-          <p:nvPr/>
-        </p:nvGraphicFramePr>
-        <p:xfrm>
-          <a:off x="640080" y="3291840"/>
-          <a:ext cx="6035040" cy="3108960"/>
-        </p:xfrm>
-        <a:graphic>
-          <a:graphicData uri="http://schemas.openxmlformats.org/drawingml/2006/chart">
-            <c:chart xmlns:c="http://schemas.openxmlformats.org/drawingml/2006/chart" r:id="rId2"/>
-          </a:graphicData>
-        </a:graphic>
-      </p:graphicFrame>
-      <p:sp>
-        <p:nvSpPr>
-          <p:cNvPr id="17" name="TextBox 16"/>
+              <a:rPr sz="2400" b="1">
+                <a:solidFill>
+                  <a:srgbClr val="ED7D31"/>
+                </a:solidFill>
+                <a:latin typeface="Calibri"/>
+              </a:rPr>
+              <a:t>➜</a:t>
+            </a:r>
+          </a:p>
+        </p:txBody>
+      </p:sp>
+      <p:sp>
+        <p:nvSpPr>
+          <p:cNvPr id="13" name="Rectangle 12"/>
+          <p:cNvSpPr/>
+          <p:nvPr/>
+        </p:nvSpPr>
+        <p:spPr>
+          <a:xfrm>
+            <a:off x="9281160" y="1828800"/>
+            <a:ext cx="2468880" cy="1097280"/>
+          </a:xfrm>
+          <a:prstGeom prst="rect">
+            <a:avLst/>
+          </a:prstGeom>
+          <a:solidFill>
+            <a:srgbClr val="1F3864"/>
+          </a:solidFill>
+          <a:ln>
+            <a:noFill/>
+          </a:ln>
+          <a:effectLst/>
+        </p:spPr>
+        <p:style>
+          <a:lnRef idx="1">
+            <a:schemeClr val="accent1"/>
+          </a:lnRef>
+          <a:fillRef idx="3">
+            <a:schemeClr val="accent1"/>
+          </a:fillRef>
+          <a:effectRef idx="2">
+            <a:schemeClr val="accent1"/>
+          </a:effectRef>
+          <a:fontRef idx="minor">
+            <a:schemeClr val="lt1"/>
+          </a:fontRef>
+        </p:style>
+        <p:txBody>
+          <a:bodyPr rtlCol="0" anchor="ctr" wrap="square"/>
+          <a:lstStyle/>
+          <a:p>
+            <a:pPr algn="ctr"/>
+            <a:r>
+              <a:rPr sz="1300" b="1">
+                <a:solidFill>
+                  <a:srgbClr val="FFFFFF"/>
+                </a:solidFill>
+              </a:rPr>
+              <a:t>Consultas
+Analíticas (DQL)</a:t>
+            </a:r>
+          </a:p>
+        </p:txBody>
+      </p:sp>
+      <p:sp>
+        <p:nvSpPr>
+          <p:cNvPr id="14" name="TextBox 13"/>
           <p:cNvSpPr txBox="1"/>
           <p:nvPr/>
         </p:nvSpPr>
         <p:spPr>
           <a:xfrm>
-            <a:off x="6949440" y="3383280"/>
-            <a:ext cx="4754880" cy="2926080"/>
+            <a:off x="640080" y="3383280"/>
+            <a:ext cx="10972800" cy="2743200"/>
           </a:xfrm>
           <a:prstGeom prst="rect">
             <a:avLst/>
@@ -9642,7 +10663,7 @@
           <a:p>
             <a:pPr>
               <a:spcAft>
-                <a:spcPts val="1000"/>
+                <a:spcPts val="900"/>
               </a:spcAft>
             </a:pPr>
             <a:r>
@@ -9652,29 +10673,29 @@
                 </a:solidFill>
                 <a:latin typeface="Calibri"/>
               </a:rPr>
-              <a:t>•  **Insight:** o crédito domina (73,9%) — parcelamento é chave;</a:t>
-            </a:r>
-          </a:p>
-          <a:p>
-            <a:pPr lvl="1">
+              <a:t>•  **Extração robusta:** BULK INSERT com FORMAT='CSV' (trata campos entre aspas).</a:t>
+            </a:r>
+          </a:p>
+          <a:p>
+            <a:pPr>
               <a:spcAft>
-                <a:spcPts val="1000"/>
+                <a:spcPts val="900"/>
               </a:spcAft>
             </a:pPr>
             <a:r>
-              <a:rPr sz="1300" b="0">
+              <a:rPr sz="1500" b="0">
                 <a:solidFill>
                   <a:srgbClr val="595959"/>
                 </a:solidFill>
                 <a:latin typeface="Calibri"/>
               </a:rPr>
-              <a:t>–  boleto ainda relevante (19%) para o público sem cartão.</a:t>
+              <a:t>•  **Valores nulos:** datas de entrega ausentes tratadas; conversão tolerante com TRY_CONVERT.</a:t>
             </a:r>
           </a:p>
           <a:p>
             <a:pPr>
               <a:spcAft>
-                <a:spcPts val="1000"/>
+                <a:spcPts val="900"/>
               </a:spcAft>
             </a:pPr>
             <a:r>
@@ -9684,13 +10705,13 @@
                 </a:solidFill>
                 <a:latin typeface="Calibri"/>
               </a:rPr>
-              <a:t>•  **Risco:** recompra de apenas 3,12% → base de compra única.</a:t>
+              <a:t>•  **Texto sujo:** avaliações com texto livre/quebras de linha → arquivo reviews_limpo pré-tratado.</a:t>
             </a:r>
           </a:p>
           <a:p>
             <a:pPr>
               <a:spcAft>
-                <a:spcPts val="1000"/>
+                <a:spcPts val="900"/>
               </a:spcAft>
             </a:pPr>
             <a:r>
@@ -9700,7 +10721,23 @@
                 </a:solidFill>
                 <a:latin typeface="Calibri"/>
               </a:rPr>
-              <a:t>•  **Ação:** CRM, pós-venda e fidelização para elevar o LTV.</a:t>
+              <a:t>•  **Formatos inconsistentes:** timestamps e decimais convertidos no momento da análise.</a:t>
+            </a:r>
+          </a:p>
+          <a:p>
+            <a:pPr>
+              <a:spcAft>
+                <a:spcPts val="900"/>
+              </a:spcAft>
+            </a:pPr>
+            <a:r>
+              <a:rPr sz="1500" b="0">
+                <a:solidFill>
+                  <a:srgbClr val="595959"/>
+                </a:solidFill>
+                <a:latin typeface="Calibri"/>
+              </a:rPr>
+              <a:t>•  **Reexecução:** scripts idempotentes (DROP IF EXISTS + recarga) garantem carga repetível.</a:t>
             </a:r>
           </a:p>
         </p:txBody>
@@ -9876,7 +10913,7 @@
                 </a:solidFill>
                 <a:latin typeface="Calibri"/>
               </a:rPr>
-              <a:t>Geografia e Sazonalidade (P3 e P4)</a:t>
+              <a:t>Pagamentos e Recompra (P1 e P2)</a:t>
             </a:r>
           </a:p>
         </p:txBody>
@@ -10001,7 +11038,7 @@
                 </a:solidFill>
                 <a:latin typeface="Calibri"/>
               </a:rPr>
-              <a:t>SP</a:t>
+              <a:t>73,9%</a:t>
             </a:r>
           </a:p>
         </p:txBody>
@@ -10036,7 +11073,7 @@
                 </a:solidFill>
                 <a:latin typeface="Calibri"/>
               </a:rPr>
-              <a:t>40.302 clientes</a:t>
+              <a:t>no cartão de crédito</a:t>
             </a:r>
           </a:p>
         </p:txBody>
@@ -10111,13 +11148,13 @@
           <a:p>
             <a:pPr algn="ctr"/>
             <a:r>
-              <a:rPr sz="2200" b="1">
+              <a:rPr sz="3000" b="1">
                 <a:solidFill>
                   <a:srgbClr val="1F3864"/>
                 </a:solidFill>
                 <a:latin typeface="Calibri"/>
               </a:rPr>
-              <a:t>Nov/2017</a:t>
+              <a:t>3,12%</a:t>
             </a:r>
           </a:p>
         </p:txBody>
@@ -10152,7 +11189,7 @@
                 </a:solidFill>
                 <a:latin typeface="Calibri"/>
               </a:rPr>
-              <a:t>pico de pedidos</a:t>
+              <a:t>taxa de recompra</a:t>
             </a:r>
           </a:p>
         </p:txBody>
@@ -10227,13 +11264,13 @@
           <a:p>
             <a:pPr algn="ctr"/>
             <a:r>
-              <a:rPr sz="3000" b="1">
+              <a:rPr sz="2200" b="1">
                 <a:solidFill>
                   <a:srgbClr val="1F3864"/>
                 </a:solidFill>
                 <a:latin typeface="Calibri"/>
               </a:rPr>
-              <a:t>Sudeste</a:t>
+              <a:t>R$ 12,5 mi</a:t>
             </a:r>
           </a:p>
         </p:txBody>
@@ -10268,7 +11305,7 @@
                 </a:solidFill>
                 <a:latin typeface="Calibri"/>
               </a:rPr>
-              <a:t>concentra a demanda</a:t>
+              <a:t>via crédito</a:t>
             </a:r>
           </a:p>
         </p:txBody>
@@ -10325,7 +11362,23 @@
                 </a:solidFill>
                 <a:latin typeface="Calibri"/>
               </a:rPr>
-              <a:t>•  **Insight:** forte concentração no Sudeste (SP/RJ/MG).</a:t>
+              <a:t>•  **Insight:** o crédito domina (73,9%) — parcelamento é chave;</a:t>
+            </a:r>
+          </a:p>
+          <a:p>
+            <a:pPr lvl="1">
+              <a:spcAft>
+                <a:spcPts val="1000"/>
+              </a:spcAft>
+            </a:pPr>
+            <a:r>
+              <a:rPr sz="1300" b="0">
+                <a:solidFill>
+                  <a:srgbClr val="595959"/>
+                </a:solidFill>
+                <a:latin typeface="Calibri"/>
+              </a:rPr>
+              <a:t>–  boleto ainda relevante (19%) para o público sem cartão.</a:t>
             </a:r>
           </a:p>
           <a:p>
@@ -10341,7 +11394,7 @@
                 </a:solidFill>
                 <a:latin typeface="Calibri"/>
               </a:rPr>
-              <a:t>•  **Sazonalidade:** pico em nov/2017 (Black Friday).</a:t>
+              <a:t>•  **Risco:** recompra de apenas 3,12% → base de compra única.</a:t>
             </a:r>
           </a:p>
           <a:p>
@@ -10357,23 +11410,7 @@
                 </a:solidFill>
                 <a:latin typeface="Calibri"/>
               </a:rPr>
-              <a:t>•  **Ação:** logística e estoque reforçados no Sudeste e</a:t>
-            </a:r>
-          </a:p>
-          <a:p>
-            <a:pPr lvl="1">
-              <a:spcAft>
-                <a:spcPts val="1000"/>
-              </a:spcAft>
-            </a:pPr>
-            <a:r>
-              <a:rPr sz="1300" b="0">
-                <a:solidFill>
-                  <a:srgbClr val="595959"/>
-                </a:solidFill>
-                <a:latin typeface="Calibri"/>
-              </a:rPr>
-              <a:t>–  campanhas planejadas para datas de pico.</a:t>
+              <a:t>•  **Ação:** CRM, pós-venda e fidelização para elevar o LTV.</a:t>
             </a:r>
           </a:p>
         </p:txBody>
@@ -10549,7 +11586,7 @@
                 </a:solidFill>
                 <a:latin typeface="Calibri"/>
               </a:rPr>
-              <a:t>Categorias e Crescimento (P5 e P6)</a:t>
+              <a:t>Geografia e Sazonalidade (P3 e P4)</a:t>
             </a:r>
           </a:p>
         </p:txBody>
@@ -10668,13 +11705,13 @@
           <a:p>
             <a:pPr algn="ctr"/>
             <a:r>
-              <a:rPr sz="1600" b="1">
+              <a:rPr sz="3000" b="1">
                 <a:solidFill>
                   <a:srgbClr val="1F3864"/>
                 </a:solidFill>
                 <a:latin typeface="Calibri"/>
               </a:rPr>
-              <a:t>cama/mesa/banho</a:t>
+              <a:t>SP</a:t>
             </a:r>
           </a:p>
         </p:txBody>
@@ -10709,7 +11746,7 @@
                 </a:solidFill>
                 <a:latin typeface="Calibri"/>
               </a:rPr>
-              <a:t>+ vendida</a:t>
+              <a:t>40.302 clientes</a:t>
             </a:r>
           </a:p>
         </p:txBody>
@@ -10784,13 +11821,13 @@
           <a:p>
             <a:pPr algn="ctr"/>
             <a:r>
-              <a:rPr sz="1600" b="1">
+              <a:rPr sz="2200" b="1">
                 <a:solidFill>
                   <a:srgbClr val="1F3864"/>
                 </a:solidFill>
                 <a:latin typeface="Calibri"/>
               </a:rPr>
-              <a:t>health_beauty</a:t>
+              <a:t>Nov/2017</a:t>
             </a:r>
           </a:p>
         </p:txBody>
@@ -10825,7 +11862,7 @@
                 </a:solidFill>
                 <a:latin typeface="Calibri"/>
               </a:rPr>
-              <a:t>+ receita</a:t>
+              <a:t>pico de pedidos</a:t>
             </a:r>
           </a:p>
         </p:txBody>
@@ -10906,7 +11943,7 @@
                 </a:solidFill>
                 <a:latin typeface="Calibri"/>
               </a:rPr>
-              <a:t>+52%</a:t>
+              <a:t>Sudeste</a:t>
             </a:r>
           </a:p>
         </p:txBody>
@@ -10941,7 +11978,7 @@
                 </a:solidFill>
                 <a:latin typeface="Calibri"/>
               </a:rPr>
-              <a:t>MoM em nov/2017</a:t>
+              <a:t>concentra a demanda</a:t>
             </a:r>
           </a:p>
         </p:txBody>
@@ -10998,7 +12035,39 @@
                 </a:solidFill>
                 <a:latin typeface="Calibri"/>
               </a:rPr>
-              <a:t>•  **Insight:** volume vem de cama/mesa/banho; receita de</a:t>
+              <a:t>•  **Insight:** forte concentração no Sudeste (SP/RJ/MG).</a:t>
+            </a:r>
+          </a:p>
+          <a:p>
+            <a:pPr>
+              <a:spcAft>
+                <a:spcPts val="1000"/>
+              </a:spcAft>
+            </a:pPr>
+            <a:r>
+              <a:rPr sz="1500" b="0">
+                <a:solidFill>
+                  <a:srgbClr val="595959"/>
+                </a:solidFill>
+                <a:latin typeface="Calibri"/>
+              </a:rPr>
+              <a:t>•  **Sazonalidade:** pico em nov/2017 (Black Friday).</a:t>
+            </a:r>
+          </a:p>
+          <a:p>
+            <a:pPr>
+              <a:spcAft>
+                <a:spcPts val="1000"/>
+              </a:spcAft>
+            </a:pPr>
+            <a:r>
+              <a:rPr sz="1500" b="0">
+                <a:solidFill>
+                  <a:srgbClr val="595959"/>
+                </a:solidFill>
+                <a:latin typeface="Calibri"/>
+              </a:rPr>
+              <a:t>•  **Ação:** logística e estoque reforçados no Sudeste e</a:t>
             </a:r>
           </a:p>
           <a:p>
@@ -11014,39 +12083,7 @@
                 </a:solidFill>
                 <a:latin typeface="Calibri"/>
               </a:rPr>
-              <a:t>–  saúde &amp; beleza e relógios/presentes (ticket maior).</a:t>
-            </a:r>
-          </a:p>
-          <a:p>
-            <a:pPr>
-              <a:spcAft>
-                <a:spcPts val="1000"/>
-              </a:spcAft>
-            </a:pPr>
-            <a:r>
-              <a:rPr sz="1500" b="0">
-                <a:solidFill>
-                  <a:srgbClr val="595959"/>
-                </a:solidFill>
-                <a:latin typeface="Calibri"/>
-              </a:rPr>
-              <a:t>•  **Tendência:** crescimento forte em 2017, estabiliza em 2018.</a:t>
-            </a:r>
-          </a:p>
-          <a:p>
-            <a:pPr>
-              <a:spcAft>
-                <a:spcPts val="1000"/>
-              </a:spcAft>
-            </a:pPr>
-            <a:r>
-              <a:rPr sz="1500" b="0">
-                <a:solidFill>
-                  <a:srgbClr val="595959"/>
-                </a:solidFill>
-                <a:latin typeface="Calibri"/>
-              </a:rPr>
-              <a:t>•  **Ação:** mix de produtos por margem e curva de demanda.</a:t>
+              <a:t>–  campanhas planejadas para datas de pico.</a:t>
             </a:r>
           </a:p>
         </p:txBody>

</xml_diff>